<commit_message>
docs: finalize five-minute presentation and validation report
</commit_message>
<xml_diff>
--- a/doc/ppt/G087_신형섭_1차발표.pptx
+++ b/doc/ppt/G087_신형섭_1차발표.pptx
@@ -2,21 +2,22 @@
 <file path=ppt/presentation.xml><?xml version="1.0" encoding="utf-8"?>
 <p:presentation xmlns:p="http://schemas.openxmlformats.org/presentationml/2006/main">
   <p:sldMasterIdLst>
-    <p:sldMasterId xmlns:r="http://schemas.openxmlformats.org/officeDocument/2006/relationships" id="2147483648" r:id="Rae7dbf1f965d4dc2"/>
+    <p:sldMasterId xmlns:r="http://schemas.openxmlformats.org/officeDocument/2006/relationships" id="2147483648" r:id="Raf53253504474739"/>
   </p:sldMasterIdLst>
   <p:notesMasterIdLst>
-    <p:notesMasterId xmlns:r="http://schemas.openxmlformats.org/officeDocument/2006/relationships" r:id="R9a2a20af1edc4aa8"/>
+    <p:notesMasterId xmlns:r="http://schemas.openxmlformats.org/officeDocument/2006/relationships" r:id="R65c4c70a12994912"/>
   </p:notesMasterIdLst>
   <p:sldIdLst>
-    <p:sldId xmlns:r="http://schemas.openxmlformats.org/officeDocument/2006/relationships" id="256" r:id="R96c03b952b8e4fc0"/>
-    <p:sldId xmlns:r="http://schemas.openxmlformats.org/officeDocument/2006/relationships" id="257" r:id="R6b03cc9cc1a042a5"/>
-    <p:sldId xmlns:r="http://schemas.openxmlformats.org/officeDocument/2006/relationships" id="258" r:id="R9636a6d3228548df"/>
-    <p:sldId xmlns:r="http://schemas.openxmlformats.org/officeDocument/2006/relationships" id="259" r:id="Rcf4bae1ec4bc4cf6"/>
-    <p:sldId xmlns:r="http://schemas.openxmlformats.org/officeDocument/2006/relationships" id="260" r:id="R8c9a09117d8c44e7"/>
-    <p:sldId xmlns:r="http://schemas.openxmlformats.org/officeDocument/2006/relationships" id="261" r:id="R289bcf4f66dc48cd"/>
-    <p:sldId xmlns:r="http://schemas.openxmlformats.org/officeDocument/2006/relationships" id="262" r:id="Rbfa0d224f7bb43ba"/>
-    <p:sldId xmlns:r="http://schemas.openxmlformats.org/officeDocument/2006/relationships" id="263" r:id="R3762764a01d749c0"/>
-    <p:sldId xmlns:r="http://schemas.openxmlformats.org/officeDocument/2006/relationships" id="264" r:id="R4db37c67aa344cd4"/>
+    <p:sldId xmlns:r="http://schemas.openxmlformats.org/officeDocument/2006/relationships" id="256" r:id="Red2352f3d6a74e4d"/>
+    <p:sldId xmlns:r="http://schemas.openxmlformats.org/officeDocument/2006/relationships" id="257" r:id="R61a55f998653470a"/>
+    <p:sldId xmlns:r="http://schemas.openxmlformats.org/officeDocument/2006/relationships" id="258" r:id="R3286eb13bc914fcd"/>
+    <p:sldId xmlns:r="http://schemas.openxmlformats.org/officeDocument/2006/relationships" id="259" r:id="R5d306e1ed6e34ffa"/>
+    <p:sldId xmlns:r="http://schemas.openxmlformats.org/officeDocument/2006/relationships" id="260" r:id="Rd90e49c423a845b9"/>
+    <p:sldId xmlns:r="http://schemas.openxmlformats.org/officeDocument/2006/relationships" id="261" r:id="R5971553a09734949"/>
+    <p:sldId xmlns:r="http://schemas.openxmlformats.org/officeDocument/2006/relationships" id="262" r:id="Re8bb7c83c89f4689"/>
+    <p:sldId xmlns:r="http://schemas.openxmlformats.org/officeDocument/2006/relationships" id="263" r:id="Raf589f71806349bf"/>
+    <p:sldId xmlns:r="http://schemas.openxmlformats.org/officeDocument/2006/relationships" id="264" r:id="R1f4a75a9ea194e3e"/>
+    <p:sldId xmlns:r="http://schemas.openxmlformats.org/officeDocument/2006/relationships" id="265" r:id="R4acf73958623407b"/>
   </p:sldIdLst>
   <p:sldSz cx="12192000" cy="6858000"/>
   <p:notesSz cx="6858000" cy="9144000"/>
@@ -460,7 +461,7 @@
           </a:p>
           <a:p xmlns:a="http://schemas.openxmlformats.org/drawingml/2006/main">
             <a:r>
-              <a:t>G087 신형섭입니다. 과제 1인 기존 Base AI Agent 개선을 선택했습니다. 조회 대상을 추측하던 정책과 키워드 런북 선택을 고치고, 전문 조사 그래프, 증분 요약 메모리, 근거 평가를 추가했습니다. 기존 FastAPI, Vue, MCP 연결과 LangGraph 구조를 재사용했습니다. 먼저 2분 동안 바뀐 기능과 결과를 보여 드리고, 이후 3분은 제가 추가하거나 확장한 Graph, MCP, RAG 코드로 설명하겠습니다.</a:t>
+              <a:t>G087 신형섭입니다. 과제 1, 기존 Base AI Agent 개선을 선택했습니다. 조회 대상을 추측하던 경로와 키워드 런북 선택을 고치고, 전문 조사 그래프, 증분 요약, 근거 평가를 추가했습니다. FastAPI, Vue, MCP와 메인 LangGraph는 재사용했습니다. 앞 2분은 수정 이유와 결과, 뒤 3분은 제가 추가하거나 확장한 Graph, MCP, RAG 코드를 설명하겠습니다.</a:t>
             </a:r>
           </a:p>
           <a:p xmlns:a="http://schemas.openxmlformats.org/drawingml/2006/main">
@@ -470,7 +471,87 @@
           </a:p>
           <a:p xmlns:a="http://schemas.openxmlformats.org/drawingml/2006/main">
             <a:r>
-              <a:t>근거: doc/ppt/s6_integration_report.md, s6_comparison.csv, s5_evaluation_report.md, limitations.md. 과제 선택·평가 기준: 제공 AI 서비스 Mini Project_20261020.pdf, PDF 11~13페이지.</a:t>
+              <a:t>근거: doc/ppt/s6_integration_report.md, s6_comparison.csv, s5_evaluation_report.md, limitations.md, model_validation.md (2026-10-22). 과제 선택·평가 기준: 제공 AI 서비스 Mini Project_20261020.pdf, PDF 11~13페이지.</a:t>
+            </a:r>
+          </a:p>
+        </p:txBody>
+      </p:sp>
+      <p:sp>
+        <p:nvSpPr>
+          <p:cNvPr id="4" name="Slide Number Placeholder 3"/>
+          <p:cNvSpPr>
+            <a:spLocks xmlns:a="http://schemas.openxmlformats.org/drawingml/2006/main" noGrp="1"/>
+          </p:cNvSpPr>
+          <p:nvPr>
+            <p:ph type="sldNum" idx="5"/>
+          </p:nvPr>
+        </p:nvSpPr>
+        <p:spPr/>
+        <p:txBody>
+          <a:bodyPr xmlns:a="http://schemas.openxmlformats.org/drawingml/2006/main"/>
+          <a:lstStyle xmlns:a="http://schemas.openxmlformats.org/drawingml/2006/main"/>
+          <a:p xmlns:a="http://schemas.openxmlformats.org/drawingml/2006/main"/>
+        </p:txBody>
+      </p:sp>
+    </p:spTree>
+  </p:cSld>
+  <p:clrMapOvr>
+    <a:masterClrMapping xmlns:a="http://schemas.openxmlformats.org/drawingml/2006/main"/>
+  </p:clrMapOvr>
+</p:notes>
+</file>
+
+<file path=ppt/notesSlides/notesSlide10.xml><?xml version="1.0" encoding="utf-8"?>
+<p:notes xmlns:p="http://schemas.openxmlformats.org/presentationml/2006/main">
+  <p:cSld>
+    <p:spTree>
+      <p:nvGrpSpPr>
+        <p:cNvPr id="1" name=""/>
+        <p:cNvGrpSpPr/>
+        <p:nvPr/>
+      </p:nvGrpSpPr>
+      <p:grpSpPr>
+        <a:xfrm xmlns:a="http://schemas.openxmlformats.org/drawingml/2006/main"/>
+      </p:grpSpPr>
+      <p:sp>
+        <p:nvSpPr>
+          <p:cNvPr id="2" name="Slide Image Placeholder 1"/>
+          <p:cNvSpPr>
+            <a:spLocks xmlns:a="http://schemas.openxmlformats.org/drawingml/2006/main" noGrp="1"/>
+          </p:cNvSpPr>
+          <p:nvPr>
+            <p:ph type="sldImg" idx="0"/>
+          </p:nvPr>
+        </p:nvSpPr>
+        <p:spPr/>
+      </p:sp>
+      <p:sp>
+        <p:nvSpPr>
+          <p:cNvPr id="3" name="Notes Placeholder 2"/>
+          <p:cNvSpPr>
+            <a:spLocks xmlns:a="http://schemas.openxmlformats.org/drawingml/2006/main" noGrp="1"/>
+          </p:cNvSpPr>
+          <p:nvPr>
+            <p:ph type="body" idx="1"/>
+          </p:nvPr>
+        </p:nvSpPr>
+        <p:spPr/>
+        <p:txBody>
+          <a:bodyPr xmlns:a="http://schemas.openxmlformats.org/drawingml/2006/main"/>
+          <a:lstStyle xmlns:a="http://schemas.openxmlformats.org/drawingml/2006/main"/>
+          <a:p xmlns:a="http://schemas.openxmlformats.org/drawingml/2006/main">
+            <a:r>
+              <a:t>2026-10-22 같은 최종 코드·설정·E5 인덱스·합성 stdio MCP로 4입력×HTTP/SSE×2백엔드×(워밍업1+측정5), 총96요청을 실행했습니다. Qwen fast/quality는 모두 qwen3:8b, OpenAI는 gpt-4o-mini/gpt-4o입니다. CPU HTTP p50은12.50초와4.70초이나 인사는1.12초와1.70초로 Qwen이 빨랐습니다. 이름 회상은 같은 한 이력의 반복10건씩이며 Qwen0/10, OpenAI10/10입니다. 지연은 품질 실패도 포함했습니다. 모델·일부 프롬프트·토크나이저가 달라 백엔드 프로필 비교입니다. 측정 OpenAI40요청 추정액은0.06398395달러, 실제 청구액은 확인하지 않았습니다. Judge 사람 확인4범주 방향 일치는 두 모델 모두4/4이며 점수 차이가 일반 정확도 향상을 뜻하지 않습니다. 취소 검증 OpenAI6건/Qwen1건은 로컬 대기 취소와 미완료 저장 방지 확인이며 원격 추론·과금 중단 보장은 아닙니다. 근거: doc/ppt/model_validation.md와 측정 결과 화면.</a:t>
+            </a:r>
+          </a:p>
+          <a:p xmlns:a="http://schemas.openxmlformats.org/drawingml/2006/main">
+            <a:r>
+              <a:t/>
+            </a:r>
+          </a:p>
+          <a:p xmlns:a="http://schemas.openxmlformats.org/drawingml/2006/main">
+            <a:r>
+              <a:t>근거: doc/ppt/s6_integration_report.md, s6_comparison.csv, s5_evaluation_report.md, limitations.md, model_validation.md (2026-10-22). 과제 선택·평가 기준: 제공 AI 서비스 Mini Project_20261020.pdf, PDF 11~13페이지.</a:t>
             </a:r>
           </a:p>
         </p:txBody>
@@ -550,7 +631,7 @@
           </a:p>
           <a:p xmlns:a="http://schemas.openxmlformats.org/drawingml/2006/main">
             <a:r>
-              <a:t>두 화면은 질문 payments-service 장애 진단, 합성 CPU 96.2%, 알림 프로세서 사용률 급증을 동일하게 준 비교입니다. LLM은 fake로 고정했고 임베딩은 실제 E5를 사용했습니다. 화면 상단 fake 실모델 표시는 기존 UI의 부정확한 표기입니다. 키워드 방식은 db-down을 골랐고, RAG는 cpu-spike를 선택했습니다. 별도의 held-out 분류 평가에서도 알려진 유형 여섯 개의 정답이 하나에서 네 개로 늘었고 미지 유형 세 개는 보류했습니다. 화면 한 쌍과 여섯 문항의 평가 집합은 구분해야 합니다.</a:t>
+              <a:t>기존 키워드 방식은 한국어 증상에서 잘못된 런북을 고를 수 있었습니다. 두 화면은 같은 질문과 합성 CPU 96.2%, 프로세서 사용률 급증을 주고 분류기만 바꾼 결과입니다. 답변 모델은 fake로 고정하고 실제 E5 임베딩을 사용했습니다. 위는 db-down, 아래 RAG는 cpu-spike를 선택합니다. 별도의 알려진 유형 6문항에서도 정답이 1개에서 4개로 늘었습니다. 미지 유형 3개는 모두 보류했습니다. 다만 화면 한 사례와 6문항 평가 집합은 서로 다릅니다.</a:t>
             </a:r>
           </a:p>
           <a:p xmlns:a="http://schemas.openxmlformats.org/drawingml/2006/main">
@@ -560,7 +641,7 @@
           </a:p>
           <a:p xmlns:a="http://schemas.openxmlformats.org/drawingml/2006/main">
             <a:r>
-              <a:t>근거: doc/ppt/s6_integration_report.md, s6_comparison.csv, s5_evaluation_report.md, limitations.md. 과제 선택·평가 기준: 제공 AI 서비스 Mini Project_20261020.pdf, PDF 11~13페이지.</a:t>
+              <a:t>근거: doc/ppt/s6_integration_report.md, s6_comparison.csv, s5_evaluation_report.md, limitations.md, model_validation.md (2026-10-22). 과제 선택·평가 기준: 제공 AI 서비스 Mini Project_20261020.pdf, PDF 11~13페이지.</a:t>
             </a:r>
           </a:p>
         </p:txBody>
@@ -640,7 +721,7 @@
           </a:p>
           <a:p xmlns:a="http://schemas.openxmlformats.org/drawingml/2006/main">
             <a:r>
-              <a:t>이 화면은 앞의 fake 비교와 달리 실제 Qwen 8B로 strict, RAG, multi, summary를 함께 적용한 Vue 실행입니다. 지표, 합성 로그, 런북을 수집하고 출처와 한계, 미실행 권고를 표시했습니다. 전체 개발 검증은 207개 통과와 기존 실패 13개이며 공개 단위 테스트만 실행한 결과는 110개 통과와 기존 실패 5개입니다. 실제 TCP 통합은 fake 13건 모두, Qwen 13건 중 11건 통과했습니다. 새 장기 기억 두 건은 실패했습니다. 여기서부터 실제 변경 코드의 구성과 호출 경계를 설명하겠습니다.</a:t>
+              <a:t>이 화면은 실제 Qwen 8B 최종 실행입니다. 지표와 합성 로그, 런북을 모으고 출처와 한계, 실행하지 않은 조치 권고를 표시합니다. 후속 검증으로 OpenAI도 같은 통합 시나리오 13건을 통과했습니다. 별도 반복 측정에서 CPU 진단 HTTP 중앙값은 Qwen 12.50초, OpenAI 4.70초였습니다. 같은 12턴 이력의 이름 회상은 Qwen 0/10, OpenAI 10/10이었습니다. Qwen은 허위 근거 ID 때문에 요약이 거부됐습니다. 한 이력의 반복이므로 일반 성능으로 확대하지 않았습니다. 이제 변경 코드의 호출 흐름을 설명하겠습니다.</a:t>
             </a:r>
           </a:p>
           <a:p xmlns:a="http://schemas.openxmlformats.org/drawingml/2006/main">
@@ -650,7 +731,7 @@
           </a:p>
           <a:p xmlns:a="http://schemas.openxmlformats.org/drawingml/2006/main">
             <a:r>
-              <a:t>근거: doc/ppt/s6_integration_report.md, s6_comparison.csv, s5_evaluation_report.md, limitations.md. 과제 선택·평가 기준: 제공 AI 서비스 Mini Project_20261020.pdf, PDF 11~13페이지.</a:t>
+              <a:t>근거: doc/ppt/s6_integration_report.md, s6_comparison.csv, s5_evaluation_report.md, limitations.md, model_validation.md (2026-10-22). 과제 선택·평가 기준: 제공 AI 서비스 Mini Project_20261020.pdf, PDF 11~13페이지.</a:t>
             </a:r>
           </a:p>
         </p:txBody>
@@ -740,7 +821,7 @@
           </a:p>
           <a:p xmlns:a="http://schemas.openxmlformats.org/drawingml/2006/main">
             <a:r>
-              <a:t>근거: doc/ppt/s6_integration_report.md, s6_comparison.csv, s5_evaluation_report.md, limitations.md. 과제 선택·평가 기준: 제공 AI 서비스 Mini Project_20261020.pdf, PDF 11~13페이지.</a:t>
+              <a:t>근거: doc/ppt/s6_integration_report.md, s6_comparison.csv, s5_evaluation_report.md, limitations.md, model_validation.md (2026-10-22). 과제 선택·평가 기준: 제공 AI 서비스 Mini Project_20261020.pdf, PDF 11~13페이지.</a:t>
             </a:r>
           </a:p>
         </p:txBody>
@@ -830,7 +911,7 @@
           </a:p>
           <a:p xmlns:a="http://schemas.openxmlformats.org/drawingml/2006/main">
             <a:r>
-              <a:t>근거: doc/ppt/s6_integration_report.md, s6_comparison.csv, s5_evaluation_report.md, limitations.md. 과제 선택·평가 기준: 제공 AI 서비스 Mini Project_20261020.pdf, PDF 11~13페이지.</a:t>
+              <a:t>근거: doc/ppt/s6_integration_report.md, s6_comparison.csv, s5_evaluation_report.md, limitations.md, model_validation.md (2026-10-22). 과제 선택·평가 기준: 제공 AI 서비스 Mini Project_20261020.pdf, PDF 11~13페이지.</a:t>
             </a:r>
           </a:p>
         </p:txBody>
@@ -910,7 +991,7 @@
           </a:p>
           <a:p xmlns:a="http://schemas.openxmlformats.org/drawingml/2006/main">
             <a:r>
-              <a:t>agent/rag/retriever.py는 수집한 모니터링 status와 alerts를 질의로 만들고 query prefix와 E5 임베딩을 적용합니다. 런북 여섯 문서는 passage prefix로 인덱싱합니다. Chroma cosine distance를 1에서 빼 점수로 사용하며 확률은 아닙니다. 표시한 decide 함수는 1위 점수가 임계값을 넘고 1, 2위 차이가 margin 이상일 때만 채택합니다. 현재 임계값은 0.8, margin은 0.01이고 top-k는 3입니다. graph.py의 replan_check는 런북이 부족할 때만 검색하고, 채택 시 유형을 gap task에 넣어 Resource를 다시 읽습니다. 보류하면 증상을 더 요청합니다. 문서와 모델 지문이 다르면 재구축 오류로 처리합니다. 구현하며 그래프 분리만으로 품질이 보장되지 않고 검색과 출처 검증이 함께 필요함을 확인했습니다. 다음에는 실패한 요약 사례를 포함해 OpenAI로 같은 조건을 교차 검증하겠습니다.</a:t>
+              <a:t>agent/rag/retriever.py는 수집한 모니터링 상태와 알림으로 검색 질의를 만들고 query prefix로 E5 임베딩을 만듭니다. 짧은 런북 6개는 문서 단위로 passage prefix를 붙여 인덱싱했습니다. Chroma cosine distance를 1에서 뺀 점수는 확률이 아닙니다. 표시한 decide 함수는 1위 점수가 0.8 이상이고 1, 2위 차이가 0.01 이상일 때만 채택합니다. top-k는 3입니다. graph.py의 replan_check는 런북이 부족할 때만 검색하고, 채택하면 장애 유형을 gap task에 넣어 MCP Resource 본문을 읽습니다. 보류하면 추가 증상을 요청합니다. 문서나 모델 지문이 달라지면 재구축 오류로 처리합니다. 이번 구현에서 구조 분리와 함께 검색·출처 검증이 필요함을 확인했습니다. 이후에는 기억 실패 사례와 실제 로그 연동을 확대하겠습니다.</a:t>
             </a:r>
           </a:p>
           <a:p xmlns:a="http://schemas.openxmlformats.org/drawingml/2006/main">
@@ -920,7 +1001,7 @@
           </a:p>
           <a:p xmlns:a="http://schemas.openxmlformats.org/drawingml/2006/main">
             <a:r>
-              <a:t>근거: doc/ppt/s6_integration_report.md, s6_comparison.csv, s5_evaluation_report.md, limitations.md. 과제 선택·평가 기준: 제공 AI 서비스 Mini Project_20261020.pdf, PDF 11~13페이지.</a:t>
+              <a:t>근거: doc/ppt/s6_integration_report.md, s6_comparison.csv, s5_evaluation_report.md, limitations.md, model_validation.md (2026-10-22). 과제 선택·평가 기준: 제공 AI 서비스 Mini Project_20261020.pdf, PDF 11~13페이지.</a:t>
             </a:r>
           </a:p>
         </p:txBody>
@@ -1000,7 +1081,7 @@
           </a:p>
           <a:p xmlns:a="http://schemas.openxmlformats.org/drawingml/2006/main">
             <a:r>
-              <a:t>근거: doc/ppt/s6_integration_report.md, s6_comparison.csv, s5_evaluation_report.md, limitations.md. 과제 선택·평가 기준: 제공 AI 서비스 Mini Project_20261020.pdf, PDF 11~13페이지.</a:t>
+              <a:t>근거: doc/ppt/s6_integration_report.md, s6_comparison.csv, s5_evaluation_report.md, limitations.md, model_validation.md (2026-10-22). 과제 선택·평가 기준: 제공 AI 서비스 Mini Project_20261020.pdf, PDF 11~13페이지.</a:t>
             </a:r>
           </a:p>
         </p:txBody>
@@ -1080,7 +1161,7 @@
           </a:p>
           <a:p xmlns:a="http://schemas.openxmlformats.org/drawingml/2006/main">
             <a:r>
-              <a:t>근거: doc/ppt/s6_integration_report.md, s6_comparison.csv, s5_evaluation_report.md, limitations.md. 과제 선택·평가 기준: 제공 AI 서비스 Mini Project_20261020.pdf, PDF 11~13페이지.</a:t>
+              <a:t>근거: doc/ppt/s6_integration_report.md, s6_comparison.csv, s5_evaluation_report.md, limitations.md, model_validation.md (2026-10-22). 과제 선택·평가 기준: 제공 AI 서비스 Mini Project_20261020.pdf, PDF 11~13페이지.</a:t>
             </a:r>
           </a:p>
         </p:txBody>
@@ -1150,7 +1231,7 @@
           <a:lstStyle xmlns:a="http://schemas.openxmlformats.org/drawingml/2006/main"/>
           <a:p xmlns:a="http://schemas.openxmlformats.org/drawingml/2006/main">
             <a:r>
-              <a:t>새 전문 그래프와 근거 계약, E5와 Chroma 검색, 증분 요약, 별도 Judge가 변경 범위입니다. 기존 MCP, DI, LangSmith 기반을 확장하고 SSE 중단 처리를 수정했습니다. 현재 남은 우선 과제는 요약 의미 보존과 실제 로그 연동입니다. 외부 모델 검증은 호출 수와 비용 상한을 정한 뒤 진행할 계획이며 아직 실행하지 않았습니다. 개인 소감은 대신 꾸며 쓰지 않고 구현에서 확인한 판단과 개선 포인트를 기록했습니다.</a:t>
+              <a:t>새 전문 그래프, 근거 계약, E5·Chroma 검색, 증분 요약과 오프라인 Judge가 변경 범위입니다. 기존 MCP·DI·LangSmith를 확장했습니다. SSE 중단 수정 9개에 OpenAI 비동기 응답 단위 6개를 추가했습니다. 전체 로컬 213 PASS/13 XFAIL, 공개 파일만으로 116 PASS/5 XFAIL입니다. OpenAI chat/write는 실제 비동기 HTTP로 바꿔 취소 시 연결을 정리합니다. route/plan/analyze는 동기 호출이 남아 있습니다. 실제 운영 로그, 요약 의미 보존, 더 큰 독립 평가 집합이 다음 과제입니다.</a:t>
             </a:r>
           </a:p>
           <a:p xmlns:a="http://schemas.openxmlformats.org/drawingml/2006/main">
@@ -1160,7 +1241,7 @@
           </a:p>
           <a:p xmlns:a="http://schemas.openxmlformats.org/drawingml/2006/main">
             <a:r>
-              <a:t>근거: doc/ppt/s6_integration_report.md, s6_comparison.csv, s5_evaluation_report.md, limitations.md. 과제 선택·평가 기준: 제공 AI 서비스 Mini Project_20261020.pdf, PDF 11~13페이지.</a:t>
+              <a:t>근거: doc/ppt/s6_integration_report.md, s6_comparison.csv, s5_evaluation_report.md, limitations.md, model_validation.md (2026-10-22). 과제 선택·평가 기준: 제공 AI 서비스 Mini Project_20261020.pdf, PDF 11~13페이지.</a:t>
             </a:r>
           </a:p>
         </p:txBody>
@@ -1207,7 +1288,7 @@
           <p:cNvPr id="3" name="Title">
             <a:extLst xmlns:a="http://schemas.openxmlformats.org/drawingml/2006/main">
               <a:ext uri="{FF2B5EF4-FFF2-40B4-BE49-F238E27FC236}">
-                <a16:creationId xmlns:a16="http://schemas.microsoft.com/office/drawing/2014/main" id="{36864F34-0A11-42E2-86EF-682549DA064D}"/>
+                <a16:creationId xmlns:a16="http://schemas.microsoft.com/office/drawing/2014/main" id="{52C7AEAA-312E-4443-B465-5D643A644F20}"/>
               </a:ext>
             </a:extLst>
           </p:cNvPr>
@@ -1436,7 +1517,7 @@
           <p:cNvPr id="2" name="Subtitle">
             <a:extLst xmlns:a="http://schemas.openxmlformats.org/drawingml/2006/main">
               <a:ext uri="{FF2B5EF4-FFF2-40B4-BE49-F238E27FC236}">
-                <a16:creationId xmlns:a16="http://schemas.microsoft.com/office/drawing/2014/main" id="{1FE65878-D39C-457B-906D-86EFAF9941A5}"/>
+                <a16:creationId xmlns:a16="http://schemas.microsoft.com/office/drawing/2014/main" id="{7F9BFA92-61EE-4B44-8D8D-4C20ACDFB4E7}"/>
               </a:ext>
             </a:extLst>
           </p:cNvPr>
@@ -1682,7 +1763,7 @@
           <p:cNvPr id="2" name="Section title">
             <a:extLst xmlns:a="http://schemas.openxmlformats.org/drawingml/2006/main">
               <a:ext uri="{FF2B5EF4-FFF2-40B4-BE49-F238E27FC236}">
-                <a16:creationId xmlns:a16="http://schemas.microsoft.com/office/drawing/2014/main" id="{6C67CFEB-7660-43DC-B1E5-B67481137D04}"/>
+                <a16:creationId xmlns:a16="http://schemas.microsoft.com/office/drawing/2014/main" id="{A486CF6E-DCCE-4A5E-8886-857F48CDF042}"/>
               </a:ext>
             </a:extLst>
           </p:cNvPr>
@@ -1928,7 +2009,7 @@
           <p:cNvPr id="3" name="Title">
             <a:extLst xmlns:a="http://schemas.openxmlformats.org/drawingml/2006/main">
               <a:ext uri="{FF2B5EF4-FFF2-40B4-BE49-F238E27FC236}">
-                <a16:creationId xmlns:a16="http://schemas.microsoft.com/office/drawing/2014/main" id="{2D119D59-06DE-43F7-AF09-ACF9DBA9FD3C}"/>
+                <a16:creationId xmlns:a16="http://schemas.microsoft.com/office/drawing/2014/main" id="{A6002FB8-F62D-4190-A84B-8339BB5EDD36}"/>
               </a:ext>
             </a:extLst>
           </p:cNvPr>
@@ -2157,7 +2238,7 @@
           <p:cNvPr id="2" name="Body">
             <a:extLst xmlns:a="http://schemas.openxmlformats.org/drawingml/2006/main">
               <a:ext uri="{FF2B5EF4-FFF2-40B4-BE49-F238E27FC236}">
-                <a16:creationId xmlns:a16="http://schemas.microsoft.com/office/drawing/2014/main" id="{57258EF2-6405-4EA3-BCA2-1F463207A7E5}"/>
+                <a16:creationId xmlns:a16="http://schemas.microsoft.com/office/drawing/2014/main" id="{0C6D2339-5C1D-48A4-895D-0B85A26B4D0B}"/>
               </a:ext>
             </a:extLst>
           </p:cNvPr>
@@ -2403,7 +2484,7 @@
           <p:cNvPr id="4" name="Title">
             <a:extLst xmlns:a="http://schemas.openxmlformats.org/drawingml/2006/main">
               <a:ext uri="{FF2B5EF4-FFF2-40B4-BE49-F238E27FC236}">
-                <a16:creationId xmlns:a16="http://schemas.microsoft.com/office/drawing/2014/main" id="{29D6836E-FC27-4E3D-ADEB-431DB2CF857A}"/>
+                <a16:creationId xmlns:a16="http://schemas.microsoft.com/office/drawing/2014/main" id="{5765E232-845D-48A1-AA14-5CD5D5464A93}"/>
               </a:ext>
             </a:extLst>
           </p:cNvPr>
@@ -2632,7 +2713,7 @@
           <p:cNvPr id="2" name="Left column">
             <a:extLst xmlns:a="http://schemas.openxmlformats.org/drawingml/2006/main">
               <a:ext uri="{FF2B5EF4-FFF2-40B4-BE49-F238E27FC236}">
-                <a16:creationId xmlns:a16="http://schemas.microsoft.com/office/drawing/2014/main" id="{16B35161-51B6-4F34-9330-21281CD722C8}"/>
+                <a16:creationId xmlns:a16="http://schemas.microsoft.com/office/drawing/2014/main" id="{1D9376CC-8049-40DE-A265-BACC7685D3BC}"/>
               </a:ext>
             </a:extLst>
           </p:cNvPr>
@@ -2861,7 +2942,7 @@
           <p:cNvPr id="3" name="Right column">
             <a:extLst xmlns:a="http://schemas.openxmlformats.org/drawingml/2006/main">
               <a:ext uri="{FF2B5EF4-FFF2-40B4-BE49-F238E27FC236}">
-                <a16:creationId xmlns:a16="http://schemas.microsoft.com/office/drawing/2014/main" id="{D07A267D-16EB-4988-B33E-9AABC921ABFF}"/>
+                <a16:creationId xmlns:a16="http://schemas.microsoft.com/office/drawing/2014/main" id="{FC128F96-A0C0-458A-B4F5-CE602CE2CD60}"/>
               </a:ext>
             </a:extLst>
           </p:cNvPr>
@@ -3107,7 +3188,7 @@
           <p:cNvPr id="3" name="Title">
             <a:extLst xmlns:a="http://schemas.openxmlformats.org/drawingml/2006/main">
               <a:ext uri="{FF2B5EF4-FFF2-40B4-BE49-F238E27FC236}">
-                <a16:creationId xmlns:a16="http://schemas.microsoft.com/office/drawing/2014/main" id="{D932A609-F30F-4421-B014-71C788A58E48}"/>
+                <a16:creationId xmlns:a16="http://schemas.microsoft.com/office/drawing/2014/main" id="{6EAFD904-EF80-41D7-98E5-1C0F4DA82E1D}"/>
               </a:ext>
             </a:extLst>
           </p:cNvPr>
@@ -3336,7 +3417,7 @@
           <p:cNvPr id="2" name="Left column">
             <a:extLst xmlns:a="http://schemas.openxmlformats.org/drawingml/2006/main">
               <a:ext uri="{FF2B5EF4-FFF2-40B4-BE49-F238E27FC236}">
-                <a16:creationId xmlns:a16="http://schemas.microsoft.com/office/drawing/2014/main" id="{862A4A35-A448-4817-9372-8F6D65FF8E9E}"/>
+                <a16:creationId xmlns:a16="http://schemas.microsoft.com/office/drawing/2014/main" id="{6F55CE36-0C90-4081-BED9-1B0FF890CA22}"/>
               </a:ext>
             </a:extLst>
           </p:cNvPr>
@@ -3603,12 +3684,12 @@
   </p:cSld>
   <p:clrMap bg1="lt1" tx1="dk1" bg2="lt2" tx2="dk2" accent1="accent1" accent2="accent2" accent3="accent3" accent4="accent4" accent5="accent5" accent6="accent6" hlink="hlink" folHlink="folHlink"/>
   <p:sldLayoutIdLst>
-    <p:sldLayoutId xmlns:r="http://schemas.openxmlformats.org/officeDocument/2006/relationships" id="2147483649" r:id="R52f8ab9737074d86"/>
-    <p:sldLayoutId xmlns:r="http://schemas.openxmlformats.org/officeDocument/2006/relationships" id="2147483650" r:id="R5d2dc9ab2d3d496c"/>
-    <p:sldLayoutId xmlns:r="http://schemas.openxmlformats.org/officeDocument/2006/relationships" id="2147483651" r:id="R0cee8f15387041da"/>
-    <p:sldLayoutId xmlns:r="http://schemas.openxmlformats.org/officeDocument/2006/relationships" id="2147483652" r:id="R8c68b41ea1a042c4"/>
-    <p:sldLayoutId xmlns:r="http://schemas.openxmlformats.org/officeDocument/2006/relationships" id="2147483653" r:id="R6dc34b9be83f4d9a"/>
-    <p:sldLayoutId xmlns:r="http://schemas.openxmlformats.org/officeDocument/2006/relationships" id="2147483654" r:id="R6d82d631ef2c4087"/>
+    <p:sldLayoutId xmlns:r="http://schemas.openxmlformats.org/officeDocument/2006/relationships" id="2147483649" r:id="R2de681fb93ff49f3"/>
+    <p:sldLayoutId xmlns:r="http://schemas.openxmlformats.org/officeDocument/2006/relationships" id="2147483650" r:id="R4528e6e04c6a4a85"/>
+    <p:sldLayoutId xmlns:r="http://schemas.openxmlformats.org/officeDocument/2006/relationships" id="2147483651" r:id="Rfabee845ec9346f5"/>
+    <p:sldLayoutId xmlns:r="http://schemas.openxmlformats.org/officeDocument/2006/relationships" id="2147483652" r:id="Raa42b7a2196a46f4"/>
+    <p:sldLayoutId xmlns:r="http://schemas.openxmlformats.org/officeDocument/2006/relationships" id="2147483653" r:id="R977e12a2096d4b1a"/>
+    <p:sldLayoutId xmlns:r="http://schemas.openxmlformats.org/officeDocument/2006/relationships" id="2147483654" r:id="R9fc483ea83bc459b"/>
   </p:sldLayoutIdLst>
   <p:txStyles>
     <p:titleStyle>
@@ -4159,7 +4240,7 @@
           <p:cNvPr id="10" name="">
             <a:extLst xmlns:a="http://schemas.openxmlformats.org/drawingml/2006/main">
               <a:ext uri="{FF2B5EF4-FFF2-40B4-BE49-F238E27FC236}">
-                <a16:creationId xmlns:a16="http://schemas.microsoft.com/office/drawing/2014/main" id="{6D9A660E-467B-480C-B66F-B47162EDDC54}"/>
+                <a16:creationId xmlns:a16="http://schemas.microsoft.com/office/drawing/2014/main" id="{CE31EA1E-ED7B-4AB8-AB33-424CB6C38F88}"/>
               </a:ext>
             </a:extLst>
           </p:cNvPr>
@@ -4315,7 +4396,7 @@
           <p:cNvPr id="2" name="">
             <a:extLst xmlns:a="http://schemas.openxmlformats.org/drawingml/2006/main">
               <a:ext uri="{FF2B5EF4-FFF2-40B4-BE49-F238E27FC236}">
-                <a16:creationId xmlns:a16="http://schemas.microsoft.com/office/drawing/2014/main" id="{73729EE4-3E3D-41FE-BF66-0A52B3983BB9}"/>
+                <a16:creationId xmlns:a16="http://schemas.microsoft.com/office/drawing/2014/main" id="{F8BD4799-3E01-4099-B085-D594E8FF638C}"/>
               </a:ext>
             </a:extLst>
           </p:cNvPr>
@@ -4471,7 +4552,7 @@
           <p:cNvPr id="3" name="">
             <a:extLst xmlns:a="http://schemas.openxmlformats.org/drawingml/2006/main">
               <a:ext uri="{FF2B5EF4-FFF2-40B4-BE49-F238E27FC236}">
-                <a16:creationId xmlns:a16="http://schemas.microsoft.com/office/drawing/2014/main" id="{7F8BFD43-B91E-433B-9B15-1E231BB73A3A}"/>
+                <a16:creationId xmlns:a16="http://schemas.microsoft.com/office/drawing/2014/main" id="{4217A150-077E-43A5-BBE9-3DD25A7DE842}"/>
               </a:ext>
             </a:extLst>
           </p:cNvPr>
@@ -4627,7 +4708,7 @@
           <p:cNvPr id="4" name="">
             <a:extLst xmlns:a="http://schemas.openxmlformats.org/drawingml/2006/main">
               <a:ext uri="{FF2B5EF4-FFF2-40B4-BE49-F238E27FC236}">
-                <a16:creationId xmlns:a16="http://schemas.microsoft.com/office/drawing/2014/main" id="{F9EFA7CE-3ED8-4B67-AF5F-7007F9D04A7B}"/>
+                <a16:creationId xmlns:a16="http://schemas.microsoft.com/office/drawing/2014/main" id="{CAA46250-54D4-4D9F-8BFE-6C224CF67201}"/>
               </a:ext>
             </a:extLst>
           </p:cNvPr>
@@ -4783,7 +4864,7 @@
           <p:cNvPr id="5" name="">
             <a:extLst xmlns:a="http://schemas.openxmlformats.org/drawingml/2006/main">
               <a:ext uri="{FF2B5EF4-FFF2-40B4-BE49-F238E27FC236}">
-                <a16:creationId xmlns:a16="http://schemas.microsoft.com/office/drawing/2014/main" id="{1B5BE68F-B63B-41BE-A4D5-822FE98DF24F}"/>
+                <a16:creationId xmlns:a16="http://schemas.microsoft.com/office/drawing/2014/main" id="{63ADB72D-7BB1-478D-B353-29CE07F1E849}"/>
               </a:ext>
             </a:extLst>
           </p:cNvPr>
@@ -4939,7 +5020,7 @@
           <p:cNvPr id="6" name="">
             <a:extLst xmlns:a="http://schemas.openxmlformats.org/drawingml/2006/main">
               <a:ext uri="{FF2B5EF4-FFF2-40B4-BE49-F238E27FC236}">
-                <a16:creationId xmlns:a16="http://schemas.microsoft.com/office/drawing/2014/main" id="{06446555-56B3-416F-B176-6116948F434D}"/>
+                <a16:creationId xmlns:a16="http://schemas.microsoft.com/office/drawing/2014/main" id="{FFB47AA2-F487-43E5-B2AE-95F1E9B87619}"/>
               </a:ext>
             </a:extLst>
           </p:cNvPr>
@@ -5118,7 +5199,7 @@
           <p:cNvPr id="7" name="">
             <a:extLst xmlns:a="http://schemas.openxmlformats.org/drawingml/2006/main">
               <a:ext uri="{FF2B5EF4-FFF2-40B4-BE49-F238E27FC236}">
-                <a16:creationId xmlns:a16="http://schemas.microsoft.com/office/drawing/2014/main" id="{58E5DA1B-4A91-43FC-B3BA-97F3EA9CFEA2}"/>
+                <a16:creationId xmlns:a16="http://schemas.microsoft.com/office/drawing/2014/main" id="{8D2DAF49-E131-41F5-B40B-2976DBD10756}"/>
               </a:ext>
             </a:extLst>
           </p:cNvPr>
@@ -5274,7 +5355,7 @@
           <p:cNvPr id="8" name="">
             <a:extLst xmlns:a="http://schemas.openxmlformats.org/drawingml/2006/main">
               <a:ext uri="{FF2B5EF4-FFF2-40B4-BE49-F238E27FC236}">
-                <a16:creationId xmlns:a16="http://schemas.microsoft.com/office/drawing/2014/main" id="{3810229E-CE58-4855-B93B-7A9DFDB08F52}"/>
+                <a16:creationId xmlns:a16="http://schemas.microsoft.com/office/drawing/2014/main" id="{2F77DDAD-7E84-43EE-80B0-E4A942B0726D}"/>
               </a:ext>
             </a:extLst>
           </p:cNvPr>
@@ -5430,7 +5511,7 @@
           <p:cNvPr id="9" name="">
             <a:extLst xmlns:a="http://schemas.openxmlformats.org/drawingml/2006/main">
               <a:ext uri="{FF2B5EF4-FFF2-40B4-BE49-F238E27FC236}">
-                <a16:creationId xmlns:a16="http://schemas.microsoft.com/office/drawing/2014/main" id="{8F4E9BFF-03D1-4985-B26A-CA0614F9220F}"/>
+                <a16:creationId xmlns:a16="http://schemas.microsoft.com/office/drawing/2014/main" id="{D2DE7E44-65C5-41F5-8D0C-48B1EE601BFA}"/>
               </a:ext>
             </a:extLst>
           </p:cNvPr>
@@ -5576,7 +5657,7 @@
                 <a:ea typeface="Apple SD Gothic Neo"/>
                 <a:cs typeface="Apple SD Gothic Neo"/>
               </a:rPr>
-              <a:t>기존 FastAPI·Vue·MCP·LangGraph를 확장했습니다. 합성 데이터 기반 Qwen 검증 결과입니다.</a:t>
+              <a:t>기존 FastAPI·Vue·MCP·LangGraph를 확장했습니다. 합성 데이터로 Qwen 구현과 OpenAI 교차 검증을 진행했습니다.</a:t>
             </a:r>
           </a:p>
         </p:txBody>
@@ -5584,7 +5665,1443 @@
     </p:spTree>
     <p:extLst>
       <p:ext uri="{BB962C8B-B14F-4D97-AF65-F5344CB8AC3E}">
-        <p14:creationId xmlns:p14="http://schemas.microsoft.com/office/powerpoint/2010/main" val="1435112595"/>
+        <p14:creationId xmlns:p14="http://schemas.microsoft.com/office/powerpoint/2010/main" val="721678329"/>
+      </p:ext>
+    </p:extLst>
+  </p:cSld>
+</p:sld>
+</file>
+
+<file path=ppt/slides/slide10.xml><?xml version="1.0" encoding="utf-8"?>
+<p:sld xmlns:p="http://schemas.openxmlformats.org/presentationml/2006/main">
+  <p:cSld>
+    <p:bg>
+      <p:bgPr>
+        <a:solidFill xmlns:a="http://schemas.openxmlformats.org/drawingml/2006/main">
+          <a:srgbClr val="FFFFFF"/>
+        </a:solidFill>
+      </p:bgPr>
+    </p:bg>
+    <p:spTree>
+      <p:nvGrpSpPr>
+        <p:cNvPr id="1" name=""/>
+        <p:cNvGrpSpPr/>
+        <p:nvPr/>
+      </p:nvGrpSpPr>
+      <p:grpSpPr>
+        <a:xfrm xmlns:a="http://schemas.openxmlformats.org/drawingml/2006/main"/>
+      </p:grpSpPr>
+      <p:sp>
+        <p:nvSpPr>
+          <p:cNvPr id="7" name="">
+            <a:extLst xmlns:a="http://schemas.openxmlformats.org/drawingml/2006/main">
+              <a:ext uri="{FF2B5EF4-FFF2-40B4-BE49-F238E27FC236}">
+                <a16:creationId xmlns:a16="http://schemas.microsoft.com/office/drawing/2014/main" id="{6FD8A423-93FE-4EEB-AC11-1FEF918B2DBB}"/>
+              </a:ext>
+            </a:extLst>
+          </p:cNvPr>
+          <p:cNvSpPr>
+            <a:spLocks xmlns:a="http://schemas.openxmlformats.org/drawingml/2006/main" noGrp="1"/>
+          </p:cNvSpPr>
+          <p:nvPr/>
+        </p:nvSpPr>
+        <p:spPr>
+          <a:xfrm xmlns:a="http://schemas.openxmlformats.org/drawingml/2006/main">
+            <a:off x="609600" y="323850"/>
+            <a:ext cx="8382000" cy="266700"/>
+          </a:xfrm>
+          <a:prstGeom xmlns:a="http://schemas.openxmlformats.org/drawingml/2006/main" prst="rect">
+            <a:avLst/>
+          </a:prstGeom>
+          <a:noFill xmlns:a="http://schemas.openxmlformats.org/drawingml/2006/main"/>
+          <a:ln xmlns:a="http://schemas.openxmlformats.org/drawingml/2006/main" w="0">
+            <a:noFill/>
+          </a:ln>
+        </p:spPr>
+        <p:txBody>
+          <a:bodyPr xmlns:a="http://schemas.openxmlformats.org/drawingml/2006/main"/>
+          <a:lstStyle xmlns:a="http://schemas.openxmlformats.org/drawingml/2006/main">
+            <a:defPPr>
+              <a:defRPr sz="1425" b="1">
+                <a:solidFill>
+                  <a:srgbClr val="087D69"/>
+                </a:solidFill>
+                <a:latin typeface="Apple SD Gothic Neo"/>
+                <a:ea typeface="Apple SD Gothic Neo"/>
+                <a:cs typeface="Apple SD Gothic Neo"/>
+              </a:defRPr>
+            </a:defPPr>
+            <a:lvl1pPr>
+              <a:defRPr sz="1425" b="1">
+                <a:solidFill>
+                  <a:srgbClr val="087D69"/>
+                </a:solidFill>
+                <a:latin typeface="Apple SD Gothic Neo"/>
+                <a:ea typeface="Apple SD Gothic Neo"/>
+                <a:cs typeface="Apple SD Gothic Neo"/>
+              </a:defRPr>
+            </a:lvl1pPr>
+            <a:lvl2pPr>
+              <a:defRPr sz="1425" b="1">
+                <a:solidFill>
+                  <a:srgbClr val="087D69"/>
+                </a:solidFill>
+                <a:latin typeface="Apple SD Gothic Neo"/>
+                <a:ea typeface="Apple SD Gothic Neo"/>
+                <a:cs typeface="Apple SD Gothic Neo"/>
+              </a:defRPr>
+            </a:lvl2pPr>
+            <a:lvl3pPr>
+              <a:defRPr sz="1425" b="1">
+                <a:solidFill>
+                  <a:srgbClr val="087D69"/>
+                </a:solidFill>
+                <a:latin typeface="Apple SD Gothic Neo"/>
+                <a:ea typeface="Apple SD Gothic Neo"/>
+                <a:cs typeface="Apple SD Gothic Neo"/>
+              </a:defRPr>
+            </a:lvl3pPr>
+            <a:lvl4pPr>
+              <a:defRPr sz="1425" b="1">
+                <a:solidFill>
+                  <a:srgbClr val="087D69"/>
+                </a:solidFill>
+                <a:latin typeface="Apple SD Gothic Neo"/>
+                <a:ea typeface="Apple SD Gothic Neo"/>
+                <a:cs typeface="Apple SD Gothic Neo"/>
+              </a:defRPr>
+            </a:lvl4pPr>
+            <a:lvl5pPr>
+              <a:defRPr sz="1425" b="1">
+                <a:solidFill>
+                  <a:srgbClr val="087D69"/>
+                </a:solidFill>
+                <a:latin typeface="Apple SD Gothic Neo"/>
+                <a:ea typeface="Apple SD Gothic Neo"/>
+                <a:cs typeface="Apple SD Gothic Neo"/>
+              </a:defRPr>
+            </a:lvl5pPr>
+            <a:lvl6pPr>
+              <a:defRPr sz="1425" b="1">
+                <a:solidFill>
+                  <a:srgbClr val="087D69"/>
+                </a:solidFill>
+                <a:latin typeface="Apple SD Gothic Neo"/>
+                <a:ea typeface="Apple SD Gothic Neo"/>
+                <a:cs typeface="Apple SD Gothic Neo"/>
+              </a:defRPr>
+            </a:lvl6pPr>
+            <a:lvl7pPr>
+              <a:defRPr sz="1425" b="1">
+                <a:solidFill>
+                  <a:srgbClr val="087D69"/>
+                </a:solidFill>
+                <a:latin typeface="Apple SD Gothic Neo"/>
+                <a:ea typeface="Apple SD Gothic Neo"/>
+                <a:cs typeface="Apple SD Gothic Neo"/>
+              </a:defRPr>
+            </a:lvl7pPr>
+            <a:lvl8pPr>
+              <a:defRPr sz="1425" b="1">
+                <a:solidFill>
+                  <a:srgbClr val="087D69"/>
+                </a:solidFill>
+                <a:latin typeface="Apple SD Gothic Neo"/>
+                <a:ea typeface="Apple SD Gothic Neo"/>
+                <a:cs typeface="Apple SD Gothic Neo"/>
+              </a:defRPr>
+            </a:lvl8pPr>
+            <a:lvl9pPr>
+              <a:defRPr sz="1425" b="1">
+                <a:solidFill>
+                  <a:srgbClr val="087D69"/>
+                </a:solidFill>
+                <a:latin typeface="Apple SD Gothic Neo"/>
+                <a:ea typeface="Apple SD Gothic Neo"/>
+                <a:cs typeface="Apple SD Gothic Neo"/>
+              </a:defRPr>
+            </a:lvl9pPr>
+          </a:lstStyle>
+          <a:p xmlns:a="http://schemas.openxmlformats.org/drawingml/2006/main">
+            <a:pPr>
+              <a:defRPr sz="1425" b="1">
+                <a:solidFill>
+                  <a:srgbClr val="087D69"/>
+                </a:solidFill>
+                <a:latin typeface="Apple SD Gothic Neo"/>
+                <a:ea typeface="Apple SD Gothic Neo"/>
+                <a:cs typeface="Apple SD Gothic Neo"/>
+              </a:defRPr>
+            </a:pPr>
+            <a:r>
+              <a:rPr sz="1425" b="1">
+                <a:solidFill>
+                  <a:srgbClr val="087D69"/>
+                </a:solidFill>
+                <a:latin typeface="Apple SD Gothic Neo"/>
+                <a:ea typeface="Apple SD Gothic Neo"/>
+                <a:cs typeface="Apple SD Gothic Neo"/>
+              </a:rPr>
+              <a:t>질의응답</a:t>
+            </a:r>
+          </a:p>
+        </p:txBody>
+      </p:sp>
+      <p:sp>
+        <p:nvSpPr>
+          <p:cNvPr id="2" name="">
+            <a:extLst xmlns:a="http://schemas.openxmlformats.org/drawingml/2006/main">
+              <a:ext uri="{FF2B5EF4-FFF2-40B4-BE49-F238E27FC236}">
+                <a16:creationId xmlns:a16="http://schemas.microsoft.com/office/drawing/2014/main" id="{DFEE2713-C877-46B8-BC2C-8868DE1B5A38}"/>
+              </a:ext>
+            </a:extLst>
+          </p:cNvPr>
+          <p:cNvSpPr>
+            <a:spLocks xmlns:a="http://schemas.openxmlformats.org/drawingml/2006/main" noGrp="1"/>
+          </p:cNvSpPr>
+          <p:nvPr/>
+        </p:nvSpPr>
+        <p:spPr>
+          <a:xfrm xmlns:a="http://schemas.openxmlformats.org/drawingml/2006/main">
+            <a:off x="9525000" y="323850"/>
+            <a:ext cx="2057400" cy="266700"/>
+          </a:xfrm>
+          <a:prstGeom xmlns:a="http://schemas.openxmlformats.org/drawingml/2006/main" prst="rect">
+            <a:avLst/>
+          </a:prstGeom>
+          <a:noFill xmlns:a="http://schemas.openxmlformats.org/drawingml/2006/main"/>
+          <a:ln xmlns:a="http://schemas.openxmlformats.org/drawingml/2006/main" w="0">
+            <a:noFill/>
+          </a:ln>
+        </p:spPr>
+        <p:txBody>
+          <a:bodyPr xmlns:a="http://schemas.openxmlformats.org/drawingml/2006/main"/>
+          <a:lstStyle xmlns:a="http://schemas.openxmlformats.org/drawingml/2006/main">
+            <a:defPPr>
+              <a:defRPr sz="1500" b="1">
+                <a:solidFill>
+                  <a:srgbClr val="173343"/>
+                </a:solidFill>
+                <a:latin typeface="Apple SD Gothic Neo"/>
+                <a:ea typeface="Apple SD Gothic Neo"/>
+                <a:cs typeface="Apple SD Gothic Neo"/>
+              </a:defRPr>
+            </a:defPPr>
+            <a:lvl1pPr>
+              <a:defRPr sz="1500" b="1">
+                <a:solidFill>
+                  <a:srgbClr val="173343"/>
+                </a:solidFill>
+                <a:latin typeface="Apple SD Gothic Neo"/>
+                <a:ea typeface="Apple SD Gothic Neo"/>
+                <a:cs typeface="Apple SD Gothic Neo"/>
+              </a:defRPr>
+            </a:lvl1pPr>
+            <a:lvl2pPr>
+              <a:defRPr sz="1500" b="1">
+                <a:solidFill>
+                  <a:srgbClr val="173343"/>
+                </a:solidFill>
+                <a:latin typeface="Apple SD Gothic Neo"/>
+                <a:ea typeface="Apple SD Gothic Neo"/>
+                <a:cs typeface="Apple SD Gothic Neo"/>
+              </a:defRPr>
+            </a:lvl2pPr>
+            <a:lvl3pPr>
+              <a:defRPr sz="1500" b="1">
+                <a:solidFill>
+                  <a:srgbClr val="173343"/>
+                </a:solidFill>
+                <a:latin typeface="Apple SD Gothic Neo"/>
+                <a:ea typeface="Apple SD Gothic Neo"/>
+                <a:cs typeface="Apple SD Gothic Neo"/>
+              </a:defRPr>
+            </a:lvl3pPr>
+            <a:lvl4pPr>
+              <a:defRPr sz="1500" b="1">
+                <a:solidFill>
+                  <a:srgbClr val="173343"/>
+                </a:solidFill>
+                <a:latin typeface="Apple SD Gothic Neo"/>
+                <a:ea typeface="Apple SD Gothic Neo"/>
+                <a:cs typeface="Apple SD Gothic Neo"/>
+              </a:defRPr>
+            </a:lvl4pPr>
+            <a:lvl5pPr>
+              <a:defRPr sz="1500" b="1">
+                <a:solidFill>
+                  <a:srgbClr val="173343"/>
+                </a:solidFill>
+                <a:latin typeface="Apple SD Gothic Neo"/>
+                <a:ea typeface="Apple SD Gothic Neo"/>
+                <a:cs typeface="Apple SD Gothic Neo"/>
+              </a:defRPr>
+            </a:lvl5pPr>
+            <a:lvl6pPr>
+              <a:defRPr sz="1500" b="1">
+                <a:solidFill>
+                  <a:srgbClr val="173343"/>
+                </a:solidFill>
+                <a:latin typeface="Apple SD Gothic Neo"/>
+                <a:ea typeface="Apple SD Gothic Neo"/>
+                <a:cs typeface="Apple SD Gothic Neo"/>
+              </a:defRPr>
+            </a:lvl6pPr>
+            <a:lvl7pPr>
+              <a:defRPr sz="1500" b="1">
+                <a:solidFill>
+                  <a:srgbClr val="173343"/>
+                </a:solidFill>
+                <a:latin typeface="Apple SD Gothic Neo"/>
+                <a:ea typeface="Apple SD Gothic Neo"/>
+                <a:cs typeface="Apple SD Gothic Neo"/>
+              </a:defRPr>
+            </a:lvl7pPr>
+            <a:lvl8pPr>
+              <a:defRPr sz="1500" b="1">
+                <a:solidFill>
+                  <a:srgbClr val="173343"/>
+                </a:solidFill>
+                <a:latin typeface="Apple SD Gothic Neo"/>
+                <a:ea typeface="Apple SD Gothic Neo"/>
+                <a:cs typeface="Apple SD Gothic Neo"/>
+              </a:defRPr>
+            </a:lvl8pPr>
+            <a:lvl9pPr>
+              <a:defRPr sz="1500" b="1">
+                <a:solidFill>
+                  <a:srgbClr val="173343"/>
+                </a:solidFill>
+                <a:latin typeface="Apple SD Gothic Neo"/>
+                <a:ea typeface="Apple SD Gothic Neo"/>
+                <a:cs typeface="Apple SD Gothic Neo"/>
+              </a:defRPr>
+            </a:lvl9pPr>
+          </a:lstStyle>
+          <a:p xmlns:a="http://schemas.openxmlformats.org/drawingml/2006/main">
+            <a:pPr>
+              <a:defRPr sz="1500" b="1">
+                <a:solidFill>
+                  <a:srgbClr val="173343"/>
+                </a:solidFill>
+                <a:latin typeface="Apple SD Gothic Neo"/>
+                <a:ea typeface="Apple SD Gothic Neo"/>
+                <a:cs typeface="Apple SD Gothic Neo"/>
+              </a:defRPr>
+            </a:pPr>
+            <a:r>
+              <a:rPr sz="1500" b="1">
+                <a:solidFill>
+                  <a:srgbClr val="173343"/>
+                </a:solidFill>
+                <a:latin typeface="Apple SD Gothic Neo"/>
+                <a:ea typeface="Apple SD Gothic Neo"/>
+                <a:cs typeface="Apple SD Gothic Neo"/>
+              </a:rPr>
+              <a:t>G087 신형섭</a:t>
+            </a:r>
+          </a:p>
+        </p:txBody>
+      </p:sp>
+      <p:sp>
+        <p:nvSpPr>
+          <p:cNvPr id="3" name="">
+            <a:extLst xmlns:a="http://schemas.openxmlformats.org/drawingml/2006/main">
+              <a:ext uri="{FF2B5EF4-FFF2-40B4-BE49-F238E27FC236}">
+                <a16:creationId xmlns:a16="http://schemas.microsoft.com/office/drawing/2014/main" id="{1FE3C78B-5696-48A3-A9F8-4927A0A7A4D4}"/>
+              </a:ext>
+            </a:extLst>
+          </p:cNvPr>
+          <p:cNvSpPr>
+            <a:spLocks xmlns:a="http://schemas.openxmlformats.org/drawingml/2006/main" noGrp="1"/>
+          </p:cNvSpPr>
+          <p:nvPr/>
+        </p:nvSpPr>
+        <p:spPr>
+          <a:xfrm xmlns:a="http://schemas.openxmlformats.org/drawingml/2006/main">
+            <a:off x="609600" y="838200"/>
+            <a:ext cx="10972800" cy="1009650"/>
+          </a:xfrm>
+          <a:prstGeom xmlns:a="http://schemas.openxmlformats.org/drawingml/2006/main" prst="rect">
+            <a:avLst/>
+          </a:prstGeom>
+          <a:noFill xmlns:a="http://schemas.openxmlformats.org/drawingml/2006/main"/>
+          <a:ln xmlns:a="http://schemas.openxmlformats.org/drawingml/2006/main" w="0">
+            <a:noFill/>
+          </a:ln>
+        </p:spPr>
+        <p:txBody>
+          <a:bodyPr xmlns:a="http://schemas.openxmlformats.org/drawingml/2006/main"/>
+          <a:lstStyle xmlns:a="http://schemas.openxmlformats.org/drawingml/2006/main">
+            <a:defPPr>
+              <a:defRPr sz="3375" b="1">
+                <a:solidFill>
+                  <a:srgbClr val="173343"/>
+                </a:solidFill>
+                <a:latin typeface="Apple SD Gothic Neo"/>
+                <a:ea typeface="Apple SD Gothic Neo"/>
+                <a:cs typeface="Apple SD Gothic Neo"/>
+              </a:defRPr>
+            </a:defPPr>
+            <a:lvl1pPr>
+              <a:defRPr sz="3375" b="1">
+                <a:solidFill>
+                  <a:srgbClr val="173343"/>
+                </a:solidFill>
+                <a:latin typeface="Apple SD Gothic Neo"/>
+                <a:ea typeface="Apple SD Gothic Neo"/>
+                <a:cs typeface="Apple SD Gothic Neo"/>
+              </a:defRPr>
+            </a:lvl1pPr>
+            <a:lvl2pPr>
+              <a:defRPr sz="3375" b="1">
+                <a:solidFill>
+                  <a:srgbClr val="173343"/>
+                </a:solidFill>
+                <a:latin typeface="Apple SD Gothic Neo"/>
+                <a:ea typeface="Apple SD Gothic Neo"/>
+                <a:cs typeface="Apple SD Gothic Neo"/>
+              </a:defRPr>
+            </a:lvl2pPr>
+            <a:lvl3pPr>
+              <a:defRPr sz="3375" b="1">
+                <a:solidFill>
+                  <a:srgbClr val="173343"/>
+                </a:solidFill>
+                <a:latin typeface="Apple SD Gothic Neo"/>
+                <a:ea typeface="Apple SD Gothic Neo"/>
+                <a:cs typeface="Apple SD Gothic Neo"/>
+              </a:defRPr>
+            </a:lvl3pPr>
+            <a:lvl4pPr>
+              <a:defRPr sz="3375" b="1">
+                <a:solidFill>
+                  <a:srgbClr val="173343"/>
+                </a:solidFill>
+                <a:latin typeface="Apple SD Gothic Neo"/>
+                <a:ea typeface="Apple SD Gothic Neo"/>
+                <a:cs typeface="Apple SD Gothic Neo"/>
+              </a:defRPr>
+            </a:lvl4pPr>
+            <a:lvl5pPr>
+              <a:defRPr sz="3375" b="1">
+                <a:solidFill>
+                  <a:srgbClr val="173343"/>
+                </a:solidFill>
+                <a:latin typeface="Apple SD Gothic Neo"/>
+                <a:ea typeface="Apple SD Gothic Neo"/>
+                <a:cs typeface="Apple SD Gothic Neo"/>
+              </a:defRPr>
+            </a:lvl5pPr>
+            <a:lvl6pPr>
+              <a:defRPr sz="3375" b="1">
+                <a:solidFill>
+                  <a:srgbClr val="173343"/>
+                </a:solidFill>
+                <a:latin typeface="Apple SD Gothic Neo"/>
+                <a:ea typeface="Apple SD Gothic Neo"/>
+                <a:cs typeface="Apple SD Gothic Neo"/>
+              </a:defRPr>
+            </a:lvl6pPr>
+            <a:lvl7pPr>
+              <a:defRPr sz="3375" b="1">
+                <a:solidFill>
+                  <a:srgbClr val="173343"/>
+                </a:solidFill>
+                <a:latin typeface="Apple SD Gothic Neo"/>
+                <a:ea typeface="Apple SD Gothic Neo"/>
+                <a:cs typeface="Apple SD Gothic Neo"/>
+              </a:defRPr>
+            </a:lvl7pPr>
+            <a:lvl8pPr>
+              <a:defRPr sz="3375" b="1">
+                <a:solidFill>
+                  <a:srgbClr val="173343"/>
+                </a:solidFill>
+                <a:latin typeface="Apple SD Gothic Neo"/>
+                <a:ea typeface="Apple SD Gothic Neo"/>
+                <a:cs typeface="Apple SD Gothic Neo"/>
+              </a:defRPr>
+            </a:lvl8pPr>
+            <a:lvl9pPr>
+              <a:defRPr sz="3375" b="1">
+                <a:solidFill>
+                  <a:srgbClr val="173343"/>
+                </a:solidFill>
+                <a:latin typeface="Apple SD Gothic Neo"/>
+                <a:ea typeface="Apple SD Gothic Neo"/>
+                <a:cs typeface="Apple SD Gothic Neo"/>
+              </a:defRPr>
+            </a:lvl9pPr>
+          </a:lstStyle>
+          <a:p xmlns:a="http://schemas.openxmlformats.org/drawingml/2006/main">
+            <a:pPr>
+              <a:defRPr sz="3375" b="1">
+                <a:solidFill>
+                  <a:srgbClr val="173343"/>
+                </a:solidFill>
+                <a:latin typeface="Apple SD Gothic Neo"/>
+                <a:ea typeface="Apple SD Gothic Neo"/>
+                <a:cs typeface="Apple SD Gothic Neo"/>
+              </a:defRPr>
+            </a:pPr>
+            <a:r>
+              <a:rPr sz="3375" b="1">
+                <a:solidFill>
+                  <a:srgbClr val="173343"/>
+                </a:solidFill>
+                <a:latin typeface="Apple SD Gothic Neo"/>
+                <a:ea typeface="Apple SD Gothic Neo"/>
+                <a:cs typeface="Apple SD Gothic Neo"/>
+              </a:rPr>
+              <a:t>부록 · Qwen과 OpenAI 교차 검증</a:t>
+            </a:r>
+          </a:p>
+        </p:txBody>
+      </p:sp>
+      <p:sp>
+        <p:nvSpPr>
+          <p:cNvPr id="4" name="">
+            <a:extLst xmlns:a="http://schemas.openxmlformats.org/drawingml/2006/main">
+              <a:ext uri="{FF2B5EF4-FFF2-40B4-BE49-F238E27FC236}">
+                <a16:creationId xmlns:a16="http://schemas.microsoft.com/office/drawing/2014/main" id="{9B2F105F-6873-4E46-AF61-D27C0CB14B06}"/>
+              </a:ext>
+            </a:extLst>
+          </p:cNvPr>
+          <p:cNvSpPr>
+            <a:spLocks xmlns:a="http://schemas.openxmlformats.org/drawingml/2006/main" noGrp="1"/>
+          </p:cNvSpPr>
+          <p:nvPr/>
+        </p:nvSpPr>
+        <p:spPr>
+          <a:xfrm xmlns:a="http://schemas.openxmlformats.org/drawingml/2006/main">
+            <a:off x="9810750" y="6381750"/>
+            <a:ext cx="1809750" cy="266700"/>
+          </a:xfrm>
+          <a:prstGeom xmlns:a="http://schemas.openxmlformats.org/drawingml/2006/main" prst="rect">
+            <a:avLst/>
+          </a:prstGeom>
+          <a:noFill xmlns:a="http://schemas.openxmlformats.org/drawingml/2006/main"/>
+          <a:ln xmlns:a="http://schemas.openxmlformats.org/drawingml/2006/main" w="0">
+            <a:noFill/>
+          </a:ln>
+        </p:spPr>
+        <p:txBody>
+          <a:bodyPr xmlns:a="http://schemas.openxmlformats.org/drawingml/2006/main"/>
+          <a:lstStyle xmlns:a="http://schemas.openxmlformats.org/drawingml/2006/main">
+            <a:defPPr>
+              <a:defRPr sz="1275" b="0">
+                <a:solidFill>
+                  <a:srgbClr val="526A77"/>
+                </a:solidFill>
+                <a:latin typeface="Apple SD Gothic Neo"/>
+                <a:ea typeface="Apple SD Gothic Neo"/>
+                <a:cs typeface="Apple SD Gothic Neo"/>
+              </a:defRPr>
+            </a:defPPr>
+            <a:lvl1pPr>
+              <a:defRPr sz="1275" b="0">
+                <a:solidFill>
+                  <a:srgbClr val="526A77"/>
+                </a:solidFill>
+                <a:latin typeface="Apple SD Gothic Neo"/>
+                <a:ea typeface="Apple SD Gothic Neo"/>
+                <a:cs typeface="Apple SD Gothic Neo"/>
+              </a:defRPr>
+            </a:lvl1pPr>
+            <a:lvl2pPr>
+              <a:defRPr sz="1275" b="0">
+                <a:solidFill>
+                  <a:srgbClr val="526A77"/>
+                </a:solidFill>
+                <a:latin typeface="Apple SD Gothic Neo"/>
+                <a:ea typeface="Apple SD Gothic Neo"/>
+                <a:cs typeface="Apple SD Gothic Neo"/>
+              </a:defRPr>
+            </a:lvl2pPr>
+            <a:lvl3pPr>
+              <a:defRPr sz="1275" b="0">
+                <a:solidFill>
+                  <a:srgbClr val="526A77"/>
+                </a:solidFill>
+                <a:latin typeface="Apple SD Gothic Neo"/>
+                <a:ea typeface="Apple SD Gothic Neo"/>
+                <a:cs typeface="Apple SD Gothic Neo"/>
+              </a:defRPr>
+            </a:lvl3pPr>
+            <a:lvl4pPr>
+              <a:defRPr sz="1275" b="0">
+                <a:solidFill>
+                  <a:srgbClr val="526A77"/>
+                </a:solidFill>
+                <a:latin typeface="Apple SD Gothic Neo"/>
+                <a:ea typeface="Apple SD Gothic Neo"/>
+                <a:cs typeface="Apple SD Gothic Neo"/>
+              </a:defRPr>
+            </a:lvl4pPr>
+            <a:lvl5pPr>
+              <a:defRPr sz="1275" b="0">
+                <a:solidFill>
+                  <a:srgbClr val="526A77"/>
+                </a:solidFill>
+                <a:latin typeface="Apple SD Gothic Neo"/>
+                <a:ea typeface="Apple SD Gothic Neo"/>
+                <a:cs typeface="Apple SD Gothic Neo"/>
+              </a:defRPr>
+            </a:lvl5pPr>
+            <a:lvl6pPr>
+              <a:defRPr sz="1275" b="0">
+                <a:solidFill>
+                  <a:srgbClr val="526A77"/>
+                </a:solidFill>
+                <a:latin typeface="Apple SD Gothic Neo"/>
+                <a:ea typeface="Apple SD Gothic Neo"/>
+                <a:cs typeface="Apple SD Gothic Neo"/>
+              </a:defRPr>
+            </a:lvl6pPr>
+            <a:lvl7pPr>
+              <a:defRPr sz="1275" b="0">
+                <a:solidFill>
+                  <a:srgbClr val="526A77"/>
+                </a:solidFill>
+                <a:latin typeface="Apple SD Gothic Neo"/>
+                <a:ea typeface="Apple SD Gothic Neo"/>
+                <a:cs typeface="Apple SD Gothic Neo"/>
+              </a:defRPr>
+            </a:lvl7pPr>
+            <a:lvl8pPr>
+              <a:defRPr sz="1275" b="0">
+                <a:solidFill>
+                  <a:srgbClr val="526A77"/>
+                </a:solidFill>
+                <a:latin typeface="Apple SD Gothic Neo"/>
+                <a:ea typeface="Apple SD Gothic Neo"/>
+                <a:cs typeface="Apple SD Gothic Neo"/>
+              </a:defRPr>
+            </a:lvl8pPr>
+            <a:lvl9pPr>
+              <a:defRPr sz="1275" b="0">
+                <a:solidFill>
+                  <a:srgbClr val="526A77"/>
+                </a:solidFill>
+                <a:latin typeface="Apple SD Gothic Neo"/>
+                <a:ea typeface="Apple SD Gothic Neo"/>
+                <a:cs typeface="Apple SD Gothic Neo"/>
+              </a:defRPr>
+            </a:lvl9pPr>
+          </a:lstStyle>
+          <a:p xmlns:a="http://schemas.openxmlformats.org/drawingml/2006/main">
+            <a:pPr>
+              <a:defRPr sz="1275" b="0">
+                <a:solidFill>
+                  <a:srgbClr val="526A77"/>
+                </a:solidFill>
+                <a:latin typeface="Apple SD Gothic Neo"/>
+                <a:ea typeface="Apple SD Gothic Neo"/>
+                <a:cs typeface="Apple SD Gothic Neo"/>
+              </a:defRPr>
+            </a:pPr>
+            <a:r>
+              <a:rPr sz="1275" b="0">
+                <a:solidFill>
+                  <a:srgbClr val="526A77"/>
+                </a:solidFill>
+                <a:latin typeface="Apple SD Gothic Neo"/>
+                <a:ea typeface="Apple SD Gothic Neo"/>
+                <a:cs typeface="Apple SD Gothic Neo"/>
+              </a:rPr>
+              <a:t>10  /  질의응답 부록</a:t>
+            </a:r>
+          </a:p>
+        </p:txBody>
+      </p:sp>
+      <p:graphicFrame>
+        <p:nvGraphicFramePr>
+          <p:cNvPr id="5" name="">
+            <a:extLst xmlns:a="http://schemas.openxmlformats.org/drawingml/2006/main">
+              <a:ext uri="{FF2B5EF4-FFF2-40B4-BE49-F238E27FC236}">
+                <a16:creationId xmlns:a16="http://schemas.microsoft.com/office/drawing/2014/main" id="{06158B5A-5804-4795-A793-C6763266362A}"/>
+              </a:ext>
+            </a:extLst>
+          </p:cNvPr>
+          <p:cNvGraphicFramePr/>
+          <p:nvPr/>
+        </p:nvGraphicFramePr>
+        <p:xfrm>
+          <a:off xmlns:a="http://schemas.openxmlformats.org/drawingml/2006/main" x="609600" y="2114550"/>
+          <a:ext xmlns:a="http://schemas.openxmlformats.org/drawingml/2006/main" cx="10972800" cy="3238500"/>
+        </p:xfrm>
+        <a:graphic xmlns:a="http://schemas.openxmlformats.org/drawingml/2006/main">
+          <a:graphicData uri="http://schemas.openxmlformats.org/drawingml/2006/table">
+            <a:tbl>
+              <a:tblPr firstRow="0" bandRow="0"/>
+              <a:tblGrid>
+                <a:gridCol w="4476750"/>
+                <a:gridCol w="3143250"/>
+                <a:gridCol w="3352800"/>
+              </a:tblGrid>
+              <a:tr h="647700">
+                <a:tc>
+                  <a:txBody>
+                    <a:bodyPr/>
+                    <a:lstStyle/>
+                    <a:p>
+                      <a:r>
+                        <a:rPr sz="1950" b="1">
+                          <a:solidFill>
+                            <a:srgbClr val="FFFFFF"/>
+                          </a:solidFill>
+                          <a:latin typeface="Apple SD Gothic Neo"/>
+                          <a:ea typeface="Apple SD Gothic Neo"/>
+                          <a:cs typeface="Apple SD Gothic Neo"/>
+                        </a:rPr>
+                        <a:t>동일 최종 코드 비교</a:t>
+                      </a:r>
+                    </a:p>
+                  </a:txBody>
+                  <a:tcPr marL="91440" marR="91440" marT="45720" marB="45720">
+                    <a:lnL w="6668">
+                      <a:solidFill>
+                        <a:srgbClr val="D6E4DF"/>
+                      </a:solidFill>
+                      <a:prstDash val="solid"/>
+                    </a:lnL>
+                    <a:lnR w="6668">
+                      <a:solidFill>
+                        <a:srgbClr val="D6E4DF"/>
+                      </a:solidFill>
+                      <a:prstDash val="solid"/>
+                    </a:lnR>
+                    <a:lnT w="6668">
+                      <a:solidFill>
+                        <a:srgbClr val="D6E4DF"/>
+                      </a:solidFill>
+                      <a:prstDash val="solid"/>
+                    </a:lnT>
+                    <a:lnB w="6668">
+                      <a:solidFill>
+                        <a:srgbClr val="D6E4DF"/>
+                      </a:solidFill>
+                      <a:prstDash val="solid"/>
+                    </a:lnB>
+                    <a:solidFill>
+                      <a:srgbClr val="173343"/>
+                    </a:solidFill>
+                  </a:tcPr>
+                </a:tc>
+                <a:tc>
+                  <a:txBody>
+                    <a:bodyPr/>
+                    <a:lstStyle/>
+                    <a:p>
+                      <a:r>
+                        <a:rPr sz="1950" b="1">
+                          <a:solidFill>
+                            <a:srgbClr val="FFFFFF"/>
+                          </a:solidFill>
+                          <a:latin typeface="Apple SD Gothic Neo"/>
+                          <a:ea typeface="Apple SD Gothic Neo"/>
+                          <a:cs typeface="Apple SD Gothic Neo"/>
+                        </a:rPr>
+                        <a:t>Qwen 8B / 8B</a:t>
+                      </a:r>
+                    </a:p>
+                  </a:txBody>
+                  <a:tcPr marL="91440" marR="91440" marT="45720" marB="45720">
+                    <a:lnR w="6668">
+                      <a:solidFill>
+                        <a:srgbClr val="D6E4DF"/>
+                      </a:solidFill>
+                      <a:prstDash val="solid"/>
+                    </a:lnR>
+                    <a:lnT w="6668">
+                      <a:solidFill>
+                        <a:srgbClr val="D6E4DF"/>
+                      </a:solidFill>
+                      <a:prstDash val="solid"/>
+                    </a:lnT>
+                    <a:lnB w="6668">
+                      <a:solidFill>
+                        <a:srgbClr val="D6E4DF"/>
+                      </a:solidFill>
+                      <a:prstDash val="solid"/>
+                    </a:lnB>
+                    <a:solidFill>
+                      <a:srgbClr val="173343"/>
+                    </a:solidFill>
+                  </a:tcPr>
+                </a:tc>
+                <a:tc>
+                  <a:txBody>
+                    <a:bodyPr/>
+                    <a:lstStyle/>
+                    <a:p>
+                      <a:r>
+                        <a:rPr sz="1950" b="1">
+                          <a:solidFill>
+                            <a:srgbClr val="FFFFFF"/>
+                          </a:solidFill>
+                          <a:latin typeface="Apple SD Gothic Neo"/>
+                          <a:ea typeface="Apple SD Gothic Neo"/>
+                          <a:cs typeface="Apple SD Gothic Neo"/>
+                        </a:rPr>
+                        <a:t>OpenAI mini / 4o</a:t>
+                      </a:r>
+                    </a:p>
+                  </a:txBody>
+                  <a:tcPr marL="91440" marR="91440" marT="45720" marB="45720">
+                    <a:lnR w="6668">
+                      <a:solidFill>
+                        <a:srgbClr val="D6E4DF"/>
+                      </a:solidFill>
+                      <a:prstDash val="solid"/>
+                    </a:lnR>
+                    <a:lnT w="6668">
+                      <a:solidFill>
+                        <a:srgbClr val="D6E4DF"/>
+                      </a:solidFill>
+                      <a:prstDash val="solid"/>
+                    </a:lnT>
+                    <a:lnB w="6668">
+                      <a:solidFill>
+                        <a:srgbClr val="D6E4DF"/>
+                      </a:solidFill>
+                      <a:prstDash val="solid"/>
+                    </a:lnB>
+                    <a:solidFill>
+                      <a:srgbClr val="173343"/>
+                    </a:solidFill>
+                  </a:tcPr>
+                </a:tc>
+              </a:tr>
+              <a:tr h="647700">
+                <a:tc>
+                  <a:txBody>
+                    <a:bodyPr/>
+                    <a:lstStyle/>
+                    <a:p>
+                      <a:r>
+                        <a:rPr sz="1950" b="0">
+                          <a:solidFill>
+                            <a:srgbClr val="173343"/>
+                          </a:solidFill>
+                          <a:latin typeface="Apple SD Gothic Neo"/>
+                          <a:ea typeface="Apple SD Gothic Neo"/>
+                          <a:cs typeface="Apple SD Gothic Neo"/>
+                        </a:rPr>
+                        <a:t>인사 HTTP p50</a:t>
+                      </a:r>
+                    </a:p>
+                  </a:txBody>
+                  <a:tcPr marL="91440" marR="91440" marT="45720" marB="45720">
+                    <a:lnL w="6668">
+                      <a:solidFill>
+                        <a:srgbClr val="D6E4DF"/>
+                      </a:solidFill>
+                      <a:prstDash val="solid"/>
+                    </a:lnL>
+                    <a:lnR w="6668">
+                      <a:solidFill>
+                        <a:srgbClr val="D6E4DF"/>
+                      </a:solidFill>
+                      <a:prstDash val="solid"/>
+                    </a:lnR>
+                    <a:lnB w="6668">
+                      <a:solidFill>
+                        <a:srgbClr val="D6E4DF"/>
+                      </a:solidFill>
+                      <a:prstDash val="solid"/>
+                    </a:lnB>
+                    <a:solidFill>
+                      <a:srgbClr val="FFFFFF"/>
+                    </a:solidFill>
+                  </a:tcPr>
+                </a:tc>
+                <a:tc>
+                  <a:txBody>
+                    <a:bodyPr/>
+                    <a:lstStyle/>
+                    <a:p>
+                      <a:r>
+                        <a:rPr sz="1950" b="0">
+                          <a:solidFill>
+                            <a:srgbClr val="173343"/>
+                          </a:solidFill>
+                          <a:latin typeface="Apple SD Gothic Neo"/>
+                          <a:ea typeface="Apple SD Gothic Neo"/>
+                          <a:cs typeface="Apple SD Gothic Neo"/>
+                        </a:rPr>
+                        <a:t>1.12초</a:t>
+                      </a:r>
+                    </a:p>
+                  </a:txBody>
+                  <a:tcPr marL="91440" marR="91440" marT="45720" marB="45720">
+                    <a:lnR w="6668">
+                      <a:solidFill>
+                        <a:srgbClr val="D6E4DF"/>
+                      </a:solidFill>
+                      <a:prstDash val="solid"/>
+                    </a:lnR>
+                    <a:lnB w="6668">
+                      <a:solidFill>
+                        <a:srgbClr val="D6E4DF"/>
+                      </a:solidFill>
+                      <a:prstDash val="solid"/>
+                    </a:lnB>
+                    <a:solidFill>
+                      <a:srgbClr val="FFFFFF"/>
+                    </a:solidFill>
+                  </a:tcPr>
+                </a:tc>
+                <a:tc>
+                  <a:txBody>
+                    <a:bodyPr/>
+                    <a:lstStyle/>
+                    <a:p>
+                      <a:r>
+                        <a:rPr sz="1950" b="0">
+                          <a:solidFill>
+                            <a:srgbClr val="173343"/>
+                          </a:solidFill>
+                          <a:latin typeface="Apple SD Gothic Neo"/>
+                          <a:ea typeface="Apple SD Gothic Neo"/>
+                          <a:cs typeface="Apple SD Gothic Neo"/>
+                        </a:rPr>
+                        <a:t>1.70초</a:t>
+                      </a:r>
+                    </a:p>
+                  </a:txBody>
+                  <a:tcPr marL="91440" marR="91440" marT="45720" marB="45720">
+                    <a:lnR w="6668">
+                      <a:solidFill>
+                        <a:srgbClr val="D6E4DF"/>
+                      </a:solidFill>
+                      <a:prstDash val="solid"/>
+                    </a:lnR>
+                    <a:lnB w="6668">
+                      <a:solidFill>
+                        <a:srgbClr val="D6E4DF"/>
+                      </a:solidFill>
+                      <a:prstDash val="solid"/>
+                    </a:lnB>
+                    <a:solidFill>
+                      <a:srgbClr val="FFFFFF"/>
+                    </a:solidFill>
+                  </a:tcPr>
+                </a:tc>
+              </a:tr>
+              <a:tr h="647700">
+                <a:tc>
+                  <a:txBody>
+                    <a:bodyPr/>
+                    <a:lstStyle/>
+                    <a:p>
+                      <a:r>
+                        <a:rPr sz="1950" b="0">
+                          <a:solidFill>
+                            <a:srgbClr val="173343"/>
+                          </a:solidFill>
+                          <a:latin typeface="Apple SD Gothic Neo"/>
+                          <a:ea typeface="Apple SD Gothic Neo"/>
+                          <a:cs typeface="Apple SD Gothic Neo"/>
+                        </a:rPr>
+                        <a:t>CPU HTTP p50</a:t>
+                      </a:r>
+                    </a:p>
+                  </a:txBody>
+                  <a:tcPr marL="91440" marR="91440" marT="45720" marB="45720">
+                    <a:lnL w="6668">
+                      <a:solidFill>
+                        <a:srgbClr val="D6E4DF"/>
+                      </a:solidFill>
+                      <a:prstDash val="solid"/>
+                    </a:lnL>
+                    <a:lnR w="6668">
+                      <a:solidFill>
+                        <a:srgbClr val="D6E4DF"/>
+                      </a:solidFill>
+                      <a:prstDash val="solid"/>
+                    </a:lnR>
+                    <a:lnB w="6668">
+                      <a:solidFill>
+                        <a:srgbClr val="D6E4DF"/>
+                      </a:solidFill>
+                      <a:prstDash val="solid"/>
+                    </a:lnB>
+                    <a:solidFill>
+                      <a:srgbClr val="FFFFFF"/>
+                    </a:solidFill>
+                  </a:tcPr>
+                </a:tc>
+                <a:tc>
+                  <a:txBody>
+                    <a:bodyPr/>
+                    <a:lstStyle/>
+                    <a:p>
+                      <a:r>
+                        <a:rPr sz="1950" b="0">
+                          <a:solidFill>
+                            <a:srgbClr val="173343"/>
+                          </a:solidFill>
+                          <a:latin typeface="Apple SD Gothic Neo"/>
+                          <a:ea typeface="Apple SD Gothic Neo"/>
+                          <a:cs typeface="Apple SD Gothic Neo"/>
+                        </a:rPr>
+                        <a:t>12.50초</a:t>
+                      </a:r>
+                    </a:p>
+                  </a:txBody>
+                  <a:tcPr marL="91440" marR="91440" marT="45720" marB="45720">
+                    <a:lnR w="6668">
+                      <a:solidFill>
+                        <a:srgbClr val="D6E4DF"/>
+                      </a:solidFill>
+                      <a:prstDash val="solid"/>
+                    </a:lnR>
+                    <a:lnB w="6668">
+                      <a:solidFill>
+                        <a:srgbClr val="D6E4DF"/>
+                      </a:solidFill>
+                      <a:prstDash val="solid"/>
+                    </a:lnB>
+                    <a:solidFill>
+                      <a:srgbClr val="FFFFFF"/>
+                    </a:solidFill>
+                  </a:tcPr>
+                </a:tc>
+                <a:tc>
+                  <a:txBody>
+                    <a:bodyPr/>
+                    <a:lstStyle/>
+                    <a:p>
+                      <a:r>
+                        <a:rPr sz="1950" b="0">
+                          <a:solidFill>
+                            <a:srgbClr val="173343"/>
+                          </a:solidFill>
+                          <a:latin typeface="Apple SD Gothic Neo"/>
+                          <a:ea typeface="Apple SD Gothic Neo"/>
+                          <a:cs typeface="Apple SD Gothic Neo"/>
+                        </a:rPr>
+                        <a:t>4.70초</a:t>
+                      </a:r>
+                    </a:p>
+                  </a:txBody>
+                  <a:tcPr marL="91440" marR="91440" marT="45720" marB="45720">
+                    <a:lnR w="6668">
+                      <a:solidFill>
+                        <a:srgbClr val="D6E4DF"/>
+                      </a:solidFill>
+                      <a:prstDash val="solid"/>
+                    </a:lnR>
+                    <a:lnB w="6668">
+                      <a:solidFill>
+                        <a:srgbClr val="D6E4DF"/>
+                      </a:solidFill>
+                      <a:prstDash val="solid"/>
+                    </a:lnB>
+                    <a:solidFill>
+                      <a:srgbClr val="FFFFFF"/>
+                    </a:solidFill>
+                  </a:tcPr>
+                </a:tc>
+              </a:tr>
+              <a:tr h="647700">
+                <a:tc>
+                  <a:txBody>
+                    <a:bodyPr/>
+                    <a:lstStyle/>
+                    <a:p>
+                      <a:r>
+                        <a:rPr sz="1950" b="0">
+                          <a:solidFill>
+                            <a:srgbClr val="173343"/>
+                          </a:solidFill>
+                          <a:latin typeface="Apple SD Gothic Neo"/>
+                          <a:ea typeface="Apple SD Gothic Neo"/>
+                          <a:cs typeface="Apple SD Gothic Neo"/>
+                        </a:rPr>
+                        <a:t>이름 회상</a:t>
+                      </a:r>
+                    </a:p>
+                  </a:txBody>
+                  <a:tcPr marL="91440" marR="91440" marT="45720" marB="45720">
+                    <a:lnL w="6668">
+                      <a:solidFill>
+                        <a:srgbClr val="D6E4DF"/>
+                      </a:solidFill>
+                      <a:prstDash val="solid"/>
+                    </a:lnL>
+                    <a:lnR w="6668">
+                      <a:solidFill>
+                        <a:srgbClr val="D6E4DF"/>
+                      </a:solidFill>
+                      <a:prstDash val="solid"/>
+                    </a:lnR>
+                    <a:lnB w="6668">
+                      <a:solidFill>
+                        <a:srgbClr val="D6E4DF"/>
+                      </a:solidFill>
+                      <a:prstDash val="solid"/>
+                    </a:lnB>
+                    <a:solidFill>
+                      <a:srgbClr val="FFFFFF"/>
+                    </a:solidFill>
+                  </a:tcPr>
+                </a:tc>
+                <a:tc>
+                  <a:txBody>
+                    <a:bodyPr/>
+                    <a:lstStyle/>
+                    <a:p>
+                      <a:r>
+                        <a:rPr sz="1950" b="0">
+                          <a:solidFill>
+                            <a:srgbClr val="173343"/>
+                          </a:solidFill>
+                          <a:latin typeface="Apple SD Gothic Neo"/>
+                          <a:ea typeface="Apple SD Gothic Neo"/>
+                          <a:cs typeface="Apple SD Gothic Neo"/>
+                        </a:rPr>
+                        <a:t>0/10</a:t>
+                      </a:r>
+                    </a:p>
+                  </a:txBody>
+                  <a:tcPr marL="91440" marR="91440" marT="45720" marB="45720">
+                    <a:lnR w="6668">
+                      <a:solidFill>
+                        <a:srgbClr val="D6E4DF"/>
+                      </a:solidFill>
+                      <a:prstDash val="solid"/>
+                    </a:lnR>
+                    <a:lnB w="6668">
+                      <a:solidFill>
+                        <a:srgbClr val="D6E4DF"/>
+                      </a:solidFill>
+                      <a:prstDash val="solid"/>
+                    </a:lnB>
+                    <a:solidFill>
+                      <a:srgbClr val="FFFFFF"/>
+                    </a:solidFill>
+                  </a:tcPr>
+                </a:tc>
+                <a:tc>
+                  <a:txBody>
+                    <a:bodyPr/>
+                    <a:lstStyle/>
+                    <a:p>
+                      <a:r>
+                        <a:rPr sz="1950" b="0">
+                          <a:solidFill>
+                            <a:srgbClr val="173343"/>
+                          </a:solidFill>
+                          <a:latin typeface="Apple SD Gothic Neo"/>
+                          <a:ea typeface="Apple SD Gothic Neo"/>
+                          <a:cs typeface="Apple SD Gothic Neo"/>
+                        </a:rPr>
+                        <a:t>10/10</a:t>
+                      </a:r>
+                    </a:p>
+                  </a:txBody>
+                  <a:tcPr marL="91440" marR="91440" marT="45720" marB="45720">
+                    <a:lnR w="6668">
+                      <a:solidFill>
+                        <a:srgbClr val="D6E4DF"/>
+                      </a:solidFill>
+                      <a:prstDash val="solid"/>
+                    </a:lnR>
+                    <a:lnB w="6668">
+                      <a:solidFill>
+                        <a:srgbClr val="D6E4DF"/>
+                      </a:solidFill>
+                      <a:prstDash val="solid"/>
+                    </a:lnB>
+                    <a:solidFill>
+                      <a:srgbClr val="FFFFFF"/>
+                    </a:solidFill>
+                  </a:tcPr>
+                </a:tc>
+              </a:tr>
+              <a:tr h="647700">
+                <a:tc>
+                  <a:txBody>
+                    <a:bodyPr/>
+                    <a:lstStyle/>
+                    <a:p>
+                      <a:r>
+                        <a:rPr sz="1950" b="0">
+                          <a:solidFill>
+                            <a:srgbClr val="173343"/>
+                          </a:solidFill>
+                          <a:latin typeface="Apple SD Gothic Neo"/>
+                          <a:ea typeface="Apple SD Gothic Neo"/>
+                          <a:cs typeface="Apple SD Gothic Neo"/>
+                        </a:rPr>
+                        <a:t>API 비용 (측정 40요청)</a:t>
+                      </a:r>
+                    </a:p>
+                  </a:txBody>
+                  <a:tcPr marL="91440" marR="91440" marT="45720" marB="45720">
+                    <a:lnL w="6668">
+                      <a:solidFill>
+                        <a:srgbClr val="D6E4DF"/>
+                      </a:solidFill>
+                      <a:prstDash val="solid"/>
+                    </a:lnL>
+                    <a:lnR w="6668">
+                      <a:solidFill>
+                        <a:srgbClr val="D6E4DF"/>
+                      </a:solidFill>
+                      <a:prstDash val="solid"/>
+                    </a:lnR>
+                    <a:lnB w="6668">
+                      <a:solidFill>
+                        <a:srgbClr val="D6E4DF"/>
+                      </a:solidFill>
+                      <a:prstDash val="solid"/>
+                    </a:lnB>
+                    <a:solidFill>
+                      <a:srgbClr val="FFFFFF"/>
+                    </a:solidFill>
+                  </a:tcPr>
+                </a:tc>
+                <a:tc>
+                  <a:txBody>
+                    <a:bodyPr/>
+                    <a:lstStyle/>
+                    <a:p>
+                      <a:r>
+                        <a:rPr sz="1950" b="0">
+                          <a:solidFill>
+                            <a:srgbClr val="173343"/>
+                          </a:solidFill>
+                          <a:latin typeface="Apple SD Gothic Neo"/>
+                          <a:ea typeface="Apple SD Gothic Neo"/>
+                          <a:cs typeface="Apple SD Gothic Neo"/>
+                        </a:rPr>
+                        <a:t>로컬 청구 $0</a:t>
+                      </a:r>
+                    </a:p>
+                  </a:txBody>
+                  <a:tcPr marL="91440" marR="91440" marT="45720" marB="45720">
+                    <a:lnR w="6668">
+                      <a:solidFill>
+                        <a:srgbClr val="D6E4DF"/>
+                      </a:solidFill>
+                      <a:prstDash val="solid"/>
+                    </a:lnR>
+                    <a:lnB w="6668">
+                      <a:solidFill>
+                        <a:srgbClr val="D6E4DF"/>
+                      </a:solidFill>
+                      <a:prstDash val="solid"/>
+                    </a:lnB>
+                    <a:solidFill>
+                      <a:srgbClr val="FFFFFF"/>
+                    </a:solidFill>
+                  </a:tcPr>
+                </a:tc>
+                <a:tc>
+                  <a:txBody>
+                    <a:bodyPr/>
+                    <a:lstStyle/>
+                    <a:p>
+                      <a:r>
+                        <a:rPr sz="1950" b="0">
+                          <a:solidFill>
+                            <a:srgbClr val="173343"/>
+                          </a:solidFill>
+                          <a:latin typeface="Apple SD Gothic Neo"/>
+                          <a:ea typeface="Apple SD Gothic Neo"/>
+                          <a:cs typeface="Apple SD Gothic Neo"/>
+                        </a:rPr>
+                        <a:t>$0.06398 추정</a:t>
+                      </a:r>
+                    </a:p>
+                  </a:txBody>
+                  <a:tcPr marL="91440" marR="91440" marT="45720" marB="45720">
+                    <a:lnR w="6668">
+                      <a:solidFill>
+                        <a:srgbClr val="D6E4DF"/>
+                      </a:solidFill>
+                      <a:prstDash val="solid"/>
+                    </a:lnR>
+                    <a:lnB w="6668">
+                      <a:solidFill>
+                        <a:srgbClr val="D6E4DF"/>
+                      </a:solidFill>
+                      <a:prstDash val="solid"/>
+                    </a:lnB>
+                    <a:solidFill>
+                      <a:srgbClr val="FFFFFF"/>
+                    </a:solidFill>
+                  </a:tcPr>
+                </a:tc>
+              </a:tr>
+            </a:tbl>
+          </a:graphicData>
+        </a:graphic>
+      </p:graphicFrame>
+      <p:sp>
+        <p:nvSpPr>
+          <p:cNvPr id="6" name="">
+            <a:extLst xmlns:a="http://schemas.openxmlformats.org/drawingml/2006/main">
+              <a:ext uri="{FF2B5EF4-FFF2-40B4-BE49-F238E27FC236}">
+                <a16:creationId xmlns:a16="http://schemas.microsoft.com/office/drawing/2014/main" id="{213F3EF8-86B4-4B7C-A9FE-27071986731B}"/>
+              </a:ext>
+            </a:extLst>
+          </p:cNvPr>
+          <p:cNvSpPr>
+            <a:spLocks xmlns:a="http://schemas.openxmlformats.org/drawingml/2006/main" noGrp="1"/>
+          </p:cNvSpPr>
+          <p:nvPr/>
+        </p:nvSpPr>
+        <p:spPr>
+          <a:xfrm xmlns:a="http://schemas.openxmlformats.org/drawingml/2006/main">
+            <a:off x="609600" y="5772150"/>
+            <a:ext cx="10953750" cy="533400"/>
+          </a:xfrm>
+          <a:prstGeom xmlns:a="http://schemas.openxmlformats.org/drawingml/2006/main" prst="rect">
+            <a:avLst/>
+          </a:prstGeom>
+          <a:noFill xmlns:a="http://schemas.openxmlformats.org/drawingml/2006/main"/>
+          <a:ln xmlns:a="http://schemas.openxmlformats.org/drawingml/2006/main" w="0">
+            <a:noFill/>
+          </a:ln>
+        </p:spPr>
+        <p:txBody>
+          <a:bodyPr xmlns:a="http://schemas.openxmlformats.org/drawingml/2006/main"/>
+          <a:lstStyle xmlns:a="http://schemas.openxmlformats.org/drawingml/2006/main">
+            <a:defPPr>
+              <a:defRPr sz="1500" b="0">
+                <a:solidFill>
+                  <a:srgbClr val="526A77"/>
+                </a:solidFill>
+                <a:latin typeface="Apple SD Gothic Neo"/>
+                <a:ea typeface="Apple SD Gothic Neo"/>
+                <a:cs typeface="Apple SD Gothic Neo"/>
+              </a:defRPr>
+            </a:defPPr>
+            <a:lvl1pPr>
+              <a:defRPr sz="1500" b="0">
+                <a:solidFill>
+                  <a:srgbClr val="526A77"/>
+                </a:solidFill>
+                <a:latin typeface="Apple SD Gothic Neo"/>
+                <a:ea typeface="Apple SD Gothic Neo"/>
+                <a:cs typeface="Apple SD Gothic Neo"/>
+              </a:defRPr>
+            </a:lvl1pPr>
+            <a:lvl2pPr>
+              <a:defRPr sz="1500" b="0">
+                <a:solidFill>
+                  <a:srgbClr val="526A77"/>
+                </a:solidFill>
+                <a:latin typeface="Apple SD Gothic Neo"/>
+                <a:ea typeface="Apple SD Gothic Neo"/>
+                <a:cs typeface="Apple SD Gothic Neo"/>
+              </a:defRPr>
+            </a:lvl2pPr>
+            <a:lvl3pPr>
+              <a:defRPr sz="1500" b="0">
+                <a:solidFill>
+                  <a:srgbClr val="526A77"/>
+                </a:solidFill>
+                <a:latin typeface="Apple SD Gothic Neo"/>
+                <a:ea typeface="Apple SD Gothic Neo"/>
+                <a:cs typeface="Apple SD Gothic Neo"/>
+              </a:defRPr>
+            </a:lvl3pPr>
+            <a:lvl4pPr>
+              <a:defRPr sz="1500" b="0">
+                <a:solidFill>
+                  <a:srgbClr val="526A77"/>
+                </a:solidFill>
+                <a:latin typeface="Apple SD Gothic Neo"/>
+                <a:ea typeface="Apple SD Gothic Neo"/>
+                <a:cs typeface="Apple SD Gothic Neo"/>
+              </a:defRPr>
+            </a:lvl4pPr>
+            <a:lvl5pPr>
+              <a:defRPr sz="1500" b="0">
+                <a:solidFill>
+                  <a:srgbClr val="526A77"/>
+                </a:solidFill>
+                <a:latin typeface="Apple SD Gothic Neo"/>
+                <a:ea typeface="Apple SD Gothic Neo"/>
+                <a:cs typeface="Apple SD Gothic Neo"/>
+              </a:defRPr>
+            </a:lvl5pPr>
+            <a:lvl6pPr>
+              <a:defRPr sz="1500" b="0">
+                <a:solidFill>
+                  <a:srgbClr val="526A77"/>
+                </a:solidFill>
+                <a:latin typeface="Apple SD Gothic Neo"/>
+                <a:ea typeface="Apple SD Gothic Neo"/>
+                <a:cs typeface="Apple SD Gothic Neo"/>
+              </a:defRPr>
+            </a:lvl6pPr>
+            <a:lvl7pPr>
+              <a:defRPr sz="1500" b="0">
+                <a:solidFill>
+                  <a:srgbClr val="526A77"/>
+                </a:solidFill>
+                <a:latin typeface="Apple SD Gothic Neo"/>
+                <a:ea typeface="Apple SD Gothic Neo"/>
+                <a:cs typeface="Apple SD Gothic Neo"/>
+              </a:defRPr>
+            </a:lvl7pPr>
+            <a:lvl8pPr>
+              <a:defRPr sz="1500" b="0">
+                <a:solidFill>
+                  <a:srgbClr val="526A77"/>
+                </a:solidFill>
+                <a:latin typeface="Apple SD Gothic Neo"/>
+                <a:ea typeface="Apple SD Gothic Neo"/>
+                <a:cs typeface="Apple SD Gothic Neo"/>
+              </a:defRPr>
+            </a:lvl8pPr>
+            <a:lvl9pPr>
+              <a:defRPr sz="1500" b="0">
+                <a:solidFill>
+                  <a:srgbClr val="526A77"/>
+                </a:solidFill>
+                <a:latin typeface="Apple SD Gothic Neo"/>
+                <a:ea typeface="Apple SD Gothic Neo"/>
+                <a:cs typeface="Apple SD Gothic Neo"/>
+              </a:defRPr>
+            </a:lvl9pPr>
+          </a:lstStyle>
+          <a:p xmlns:a="http://schemas.openxmlformats.org/drawingml/2006/main">
+            <a:pPr>
+              <a:defRPr sz="1500" b="0">
+                <a:solidFill>
+                  <a:srgbClr val="526A77"/>
+                </a:solidFill>
+                <a:latin typeface="Apple SD Gothic Neo"/>
+                <a:ea typeface="Apple SD Gothic Neo"/>
+                <a:cs typeface="Apple SD Gothic Neo"/>
+              </a:defRPr>
+            </a:pPr>
+            <a:r>
+              <a:rPr sz="1500" b="0">
+                <a:solidFill>
+                  <a:srgbClr val="526A77"/>
+                </a:solidFill>
+                <a:latin typeface="Apple SD Gothic Neo"/>
+                <a:ea typeface="Apple SD Gothic Neo"/>
+                <a:cs typeface="Apple SD Gothic Neo"/>
+              </a:rPr>
+              <a:t>96요청 중 측정 80건. 지연 조건당 n=5, 회상은 같은 한 이력의 반복. 실제 청구·전력 비용 미측정.</a:t>
+            </a:r>
+          </a:p>
+        </p:txBody>
+      </p:sp>
+    </p:spTree>
+    <p:extLst>
+      <p:ext uri="{BB962C8B-B14F-4D97-AF65-F5344CB8AC3E}">
+        <p14:creationId xmlns:p14="http://schemas.microsoft.com/office/powerpoint/2010/main" val="1078523280"/>
       </p:ext>
     </p:extLst>
   </p:cSld>
@@ -5615,7 +7132,7 @@
           <p:cNvPr id="12" name="">
             <a:extLst xmlns:a="http://schemas.openxmlformats.org/drawingml/2006/main">
               <a:ext uri="{FF2B5EF4-FFF2-40B4-BE49-F238E27FC236}">
-                <a16:creationId xmlns:a16="http://schemas.microsoft.com/office/drawing/2014/main" id="{6CAA3959-B577-4B76-AF68-34860FB46625}"/>
+                <a16:creationId xmlns:a16="http://schemas.microsoft.com/office/drawing/2014/main" id="{7FAA5BE5-8B84-4E8B-9A98-E4FEB9C8596A}"/>
               </a:ext>
             </a:extLst>
           </p:cNvPr>
@@ -5771,7 +7288,7 @@
           <p:cNvPr id="2" name="">
             <a:extLst xmlns:a="http://schemas.openxmlformats.org/drawingml/2006/main">
               <a:ext uri="{FF2B5EF4-FFF2-40B4-BE49-F238E27FC236}">
-                <a16:creationId xmlns:a16="http://schemas.microsoft.com/office/drawing/2014/main" id="{73264CA6-26FD-43DE-8B6F-8EEB8DEBA8A7}"/>
+                <a16:creationId xmlns:a16="http://schemas.microsoft.com/office/drawing/2014/main" id="{44B45B19-DA83-42DA-A78D-B472A98D1AFE}"/>
               </a:ext>
             </a:extLst>
           </p:cNvPr>
@@ -5927,7 +7444,7 @@
           <p:cNvPr id="3" name="">
             <a:extLst xmlns:a="http://schemas.openxmlformats.org/drawingml/2006/main">
               <a:ext uri="{FF2B5EF4-FFF2-40B4-BE49-F238E27FC236}">
-                <a16:creationId xmlns:a16="http://schemas.microsoft.com/office/drawing/2014/main" id="{30A8D6D3-FF69-433A-B2D0-BC13B32EB84F}"/>
+                <a16:creationId xmlns:a16="http://schemas.microsoft.com/office/drawing/2014/main" id="{ED14A2EA-D95E-47FC-9B63-6329C8B1FE55}"/>
               </a:ext>
             </a:extLst>
           </p:cNvPr>
@@ -6083,7 +7600,7 @@
           <p:cNvPr id="4" name="">
             <a:extLst xmlns:a="http://schemas.openxmlformats.org/drawingml/2006/main">
               <a:ext uri="{FF2B5EF4-FFF2-40B4-BE49-F238E27FC236}">
-                <a16:creationId xmlns:a16="http://schemas.microsoft.com/office/drawing/2014/main" id="{7B6DC910-4588-408C-BCFF-B45BBBA7F5DA}"/>
+                <a16:creationId xmlns:a16="http://schemas.microsoft.com/office/drawing/2014/main" id="{B3BCBD52-D6E9-4D28-ABB7-E31FBC0E9873}"/>
               </a:ext>
             </a:extLst>
           </p:cNvPr>
@@ -6239,7 +7756,7 @@
           <p:cNvPr id="5" name="">
             <a:extLst xmlns:a="http://schemas.openxmlformats.org/drawingml/2006/main">
               <a:ext uri="{FF2B5EF4-FFF2-40B4-BE49-F238E27FC236}">
-                <a16:creationId xmlns:a16="http://schemas.microsoft.com/office/drawing/2014/main" id="{94399D55-C71E-4593-8FCB-14A2D7C1E950}"/>
+                <a16:creationId xmlns:a16="http://schemas.microsoft.com/office/drawing/2014/main" id="{F1F43FB3-F6CF-43BC-A9B5-5882B0B9D5C7}"/>
               </a:ext>
             </a:extLst>
           </p:cNvPr>
@@ -6395,7 +7912,7 @@
           <p:cNvPr id="6" name="">
             <a:extLst xmlns:a="http://schemas.openxmlformats.org/drawingml/2006/main">
               <a:ext uri="{FF2B5EF4-FFF2-40B4-BE49-F238E27FC236}">
-                <a16:creationId xmlns:a16="http://schemas.microsoft.com/office/drawing/2014/main" id="{FE758709-6183-4CB2-94E7-B9CD7896A29F}"/>
+                <a16:creationId xmlns:a16="http://schemas.microsoft.com/office/drawing/2014/main" id="{51086EC1-35FA-4530-B33D-86D6D120C544}"/>
               </a:ext>
             </a:extLst>
           </p:cNvPr>
@@ -6551,7 +8068,7 @@
           <p:cNvPr id="7" name="">
             <a:extLst xmlns:a="http://schemas.openxmlformats.org/drawingml/2006/main">
               <a:ext uri="{FF2B5EF4-FFF2-40B4-BE49-F238E27FC236}">
-                <a16:creationId xmlns:a16="http://schemas.microsoft.com/office/drawing/2014/main" id="{B7CE8B0C-EA84-4A66-980B-B444FD155AB1}"/>
+                <a16:creationId xmlns:a16="http://schemas.microsoft.com/office/drawing/2014/main" id="{F60DC26B-30A3-4030-A45A-D87E4359457F}"/>
               </a:ext>
             </a:extLst>
           </p:cNvPr>
@@ -6561,7 +8078,7 @@
           <p:nvPr/>
         </p:nvPicPr>
         <p:blipFill>
-          <a:blip xmlns:r="http://schemas.openxmlformats.org/officeDocument/2006/relationships" xmlns:a="http://schemas.openxmlformats.org/drawingml/2006/main" r:embed="Rebb9eb1a5e854229"/>
+          <a:blip xmlns:r="http://schemas.openxmlformats.org/officeDocument/2006/relationships" xmlns:a="http://schemas.openxmlformats.org/drawingml/2006/main" r:embed="R7a5ccb348f164aa9"/>
           <a:srcRect xmlns:a="http://schemas.openxmlformats.org/drawingml/2006/main" l="1000" t="52000" r="30000" b="36000"/>
           <a:stretch xmlns:a="http://schemas.openxmlformats.org/drawingml/2006/main"/>
         </p:blipFill>
@@ -6580,7 +8097,7 @@
           <p:cNvPr id="8" name="">
             <a:extLst xmlns:a="http://schemas.openxmlformats.org/drawingml/2006/main">
               <a:ext uri="{FF2B5EF4-FFF2-40B4-BE49-F238E27FC236}">
-                <a16:creationId xmlns:a16="http://schemas.microsoft.com/office/drawing/2014/main" id="{83E9A23F-E9CF-402F-B7EA-5509224123B1}"/>
+                <a16:creationId xmlns:a16="http://schemas.microsoft.com/office/drawing/2014/main" id="{27B17A5C-2744-4CD9-935E-7C871E245124}"/>
               </a:ext>
             </a:extLst>
           </p:cNvPr>
@@ -6736,7 +8253,7 @@
           <p:cNvPr id="9" name="">
             <a:extLst xmlns:a="http://schemas.openxmlformats.org/drawingml/2006/main">
               <a:ext uri="{FF2B5EF4-FFF2-40B4-BE49-F238E27FC236}">
-                <a16:creationId xmlns:a16="http://schemas.microsoft.com/office/drawing/2014/main" id="{27F5C435-611A-4C8F-985D-6297C1E5D518}"/>
+                <a16:creationId xmlns:a16="http://schemas.microsoft.com/office/drawing/2014/main" id="{1BF3D68D-72F7-42B8-BF5C-84C32B7D361C}"/>
               </a:ext>
             </a:extLst>
           </p:cNvPr>
@@ -6746,7 +8263,7 @@
           <p:nvPr/>
         </p:nvPicPr>
         <p:blipFill>
-          <a:blip xmlns:r="http://schemas.openxmlformats.org/officeDocument/2006/relationships" xmlns:a="http://schemas.openxmlformats.org/drawingml/2006/main" r:embed="Rf560393b287b4857"/>
+          <a:blip xmlns:r="http://schemas.openxmlformats.org/officeDocument/2006/relationships" xmlns:a="http://schemas.openxmlformats.org/drawingml/2006/main" r:embed="R9cf5217099dd441a"/>
           <a:srcRect xmlns:a="http://schemas.openxmlformats.org/drawingml/2006/main" l="1000" t="52000" r="30000" b="36000"/>
           <a:stretch xmlns:a="http://schemas.openxmlformats.org/drawingml/2006/main"/>
         </p:blipFill>
@@ -6765,7 +8282,7 @@
           <p:cNvPr id="10" name="">
             <a:extLst xmlns:a="http://schemas.openxmlformats.org/drawingml/2006/main">
               <a:ext uri="{FF2B5EF4-FFF2-40B4-BE49-F238E27FC236}">
-                <a16:creationId xmlns:a16="http://schemas.microsoft.com/office/drawing/2014/main" id="{1D147037-2C92-4F67-A74D-C1688BCC5ACD}"/>
+                <a16:creationId xmlns:a16="http://schemas.microsoft.com/office/drawing/2014/main" id="{E4F89E49-AFB8-4939-A0A3-EB194F2BB798}"/>
               </a:ext>
             </a:extLst>
           </p:cNvPr>
@@ -6921,7 +8438,7 @@
           <p:cNvPr id="11" name="">
             <a:extLst xmlns:a="http://schemas.openxmlformats.org/drawingml/2006/main">
               <a:ext uri="{FF2B5EF4-FFF2-40B4-BE49-F238E27FC236}">
-                <a16:creationId xmlns:a16="http://schemas.microsoft.com/office/drawing/2014/main" id="{A6E63900-B1C0-4471-9E9E-F809B354CA50}"/>
+                <a16:creationId xmlns:a16="http://schemas.microsoft.com/office/drawing/2014/main" id="{FBF3D71C-71D5-46B0-B231-101D045BF091}"/>
               </a:ext>
             </a:extLst>
           </p:cNvPr>
@@ -7075,7 +8592,7 @@
     </p:spTree>
     <p:extLst>
       <p:ext uri="{BB962C8B-B14F-4D97-AF65-F5344CB8AC3E}">
-        <p14:creationId xmlns:p14="http://schemas.microsoft.com/office/powerpoint/2010/main" val="1048029616"/>
+        <p14:creationId xmlns:p14="http://schemas.microsoft.com/office/powerpoint/2010/main" val="6244204"/>
       </p:ext>
     </p:extLst>
   </p:cSld>
@@ -7103,10 +8620,10 @@
       </p:grpSpPr>
       <p:sp>
         <p:nvSpPr>
-          <p:cNvPr id="11" name="">
+          <p:cNvPr id="12" name="">
             <a:extLst xmlns:a="http://schemas.openxmlformats.org/drawingml/2006/main">
               <a:ext uri="{FF2B5EF4-FFF2-40B4-BE49-F238E27FC236}">
-                <a16:creationId xmlns:a16="http://schemas.microsoft.com/office/drawing/2014/main" id="{1955A113-340A-4218-AAB8-A0A0CED91DD7}"/>
+                <a16:creationId xmlns:a16="http://schemas.microsoft.com/office/drawing/2014/main" id="{EB91BBDF-7942-44AC-9453-07D2EC25D4A4}"/>
               </a:ext>
             </a:extLst>
           </p:cNvPr>
@@ -7262,7 +8779,7 @@
           <p:cNvPr id="2" name="">
             <a:extLst xmlns:a="http://schemas.openxmlformats.org/drawingml/2006/main">
               <a:ext uri="{FF2B5EF4-FFF2-40B4-BE49-F238E27FC236}">
-                <a16:creationId xmlns:a16="http://schemas.microsoft.com/office/drawing/2014/main" id="{963A0FE3-88AC-4E6C-907B-523B042A46BC}"/>
+                <a16:creationId xmlns:a16="http://schemas.microsoft.com/office/drawing/2014/main" id="{CB4705B6-02CE-4FEC-AC09-7F0556D5B03E}"/>
               </a:ext>
             </a:extLst>
           </p:cNvPr>
@@ -7418,7 +8935,7 @@
           <p:cNvPr id="3" name="">
             <a:extLst xmlns:a="http://schemas.openxmlformats.org/drawingml/2006/main">
               <a:ext uri="{FF2B5EF4-FFF2-40B4-BE49-F238E27FC236}">
-                <a16:creationId xmlns:a16="http://schemas.microsoft.com/office/drawing/2014/main" id="{6A807ECB-D212-46B7-9640-F3AB36DD75DC}"/>
+                <a16:creationId xmlns:a16="http://schemas.microsoft.com/office/drawing/2014/main" id="{35E4EB07-C777-4AE3-ACDC-EDAFB224487D}"/>
               </a:ext>
             </a:extLst>
           </p:cNvPr>
@@ -7574,7 +9091,7 @@
           <p:cNvPr id="4" name="">
             <a:extLst xmlns:a="http://schemas.openxmlformats.org/drawingml/2006/main">
               <a:ext uri="{FF2B5EF4-FFF2-40B4-BE49-F238E27FC236}">
-                <a16:creationId xmlns:a16="http://schemas.microsoft.com/office/drawing/2014/main" id="{E7A3D42E-6B3A-4C17-97D4-7A372AF20FCD}"/>
+                <a16:creationId xmlns:a16="http://schemas.microsoft.com/office/drawing/2014/main" id="{30E4EB85-0098-4CF6-B508-C02FC4017F42}"/>
               </a:ext>
             </a:extLst>
           </p:cNvPr>
@@ -7730,7 +9247,7 @@
           <p:cNvPr id="5" name="">
             <a:extLst xmlns:a="http://schemas.openxmlformats.org/drawingml/2006/main">
               <a:ext uri="{FF2B5EF4-FFF2-40B4-BE49-F238E27FC236}">
-                <a16:creationId xmlns:a16="http://schemas.microsoft.com/office/drawing/2014/main" id="{E59E1279-97CA-4587-8136-A91523BAC014}"/>
+                <a16:creationId xmlns:a16="http://schemas.microsoft.com/office/drawing/2014/main" id="{29C5C5C8-2EC8-4AAF-BF5F-2D89A3A0BDF2}"/>
               </a:ext>
             </a:extLst>
           </p:cNvPr>
@@ -7740,7 +9257,7 @@
           <p:nvPr/>
         </p:nvPicPr>
         <p:blipFill>
-          <a:blip xmlns:r="http://schemas.openxmlformats.org/officeDocument/2006/relationships" xmlns:a="http://schemas.openxmlformats.org/drawingml/2006/main" r:embed="Rf893f99ba2124393"/>
+          <a:blip xmlns:r="http://schemas.openxmlformats.org/officeDocument/2006/relationships" xmlns:a="http://schemas.openxmlformats.org/drawingml/2006/main" r:embed="Re5ca661099b34117"/>
           <a:stretch xmlns:a="http://schemas.openxmlformats.org/drawingml/2006/main"/>
         </p:blipFill>
         <p:spPr>
@@ -7758,7 +9275,7 @@
           <p:cNvPr id="6" name="">
             <a:extLst xmlns:a="http://schemas.openxmlformats.org/drawingml/2006/main">
               <a:ext uri="{FF2B5EF4-FFF2-40B4-BE49-F238E27FC236}">
-                <a16:creationId xmlns:a16="http://schemas.microsoft.com/office/drawing/2014/main" id="{BC064E7B-624B-4CF8-B3CE-BBAD648ADCF3}"/>
+                <a16:creationId xmlns:a16="http://schemas.microsoft.com/office/drawing/2014/main" id="{AD65A792-BD25-42B4-9368-5BCA7611E5FA}"/>
               </a:ext>
             </a:extLst>
           </p:cNvPr>
@@ -7914,7 +9431,7 @@
           <p:cNvPr id="7" name="">
             <a:extLst xmlns:a="http://schemas.openxmlformats.org/drawingml/2006/main">
               <a:ext uri="{FF2B5EF4-FFF2-40B4-BE49-F238E27FC236}">
-                <a16:creationId xmlns:a16="http://schemas.microsoft.com/office/drawing/2014/main" id="{1E5E7CDE-B64C-49F0-94A9-C0EF9B6965EB}"/>
+                <a16:creationId xmlns:a16="http://schemas.microsoft.com/office/drawing/2014/main" id="{B113FEC5-207B-4EF5-8286-CA258F859A0D}"/>
               </a:ext>
             </a:extLst>
           </p:cNvPr>
@@ -8093,7 +9610,7 @@
           <p:cNvPr id="8" name="">
             <a:extLst xmlns:a="http://schemas.openxmlformats.org/drawingml/2006/main">
               <a:ext uri="{FF2B5EF4-FFF2-40B4-BE49-F238E27FC236}">
-                <a16:creationId xmlns:a16="http://schemas.microsoft.com/office/drawing/2014/main" id="{DCDD922E-4D54-4DAB-883D-E793C463DE31}"/>
+                <a16:creationId xmlns:a16="http://schemas.microsoft.com/office/drawing/2014/main" id="{7E99A636-FCEF-4380-9E30-5EB6C786D0C7}"/>
               </a:ext>
             </a:extLst>
           </p:cNvPr>
@@ -8104,7 +9621,7 @@
         </p:nvSpPr>
         <p:spPr>
           <a:xfrm xmlns:a="http://schemas.openxmlformats.org/drawingml/2006/main">
-            <a:off x="8134350" y="3733800"/>
+            <a:off x="8134350" y="3638550"/>
             <a:ext cx="3429000" cy="800100"/>
           </a:xfrm>
           <a:prstGeom xmlns:a="http://schemas.openxmlformats.org/drawingml/2006/main" prst="rect">
@@ -8119,7 +9636,7 @@
           <a:bodyPr xmlns:a="http://schemas.openxmlformats.org/drawingml/2006/main"/>
           <a:lstStyle xmlns:a="http://schemas.openxmlformats.org/drawingml/2006/main">
             <a:defPPr>
-              <a:defRPr sz="2100" b="1">
+              <a:defRPr sz="2025" b="1">
                 <a:solidFill>
                   <a:srgbClr val="173343"/>
                 </a:solidFill>
@@ -8129,7 +9646,7 @@
               </a:defRPr>
             </a:defPPr>
             <a:lvl1pPr>
-              <a:defRPr sz="2100" b="1">
+              <a:defRPr sz="2025" b="1">
                 <a:solidFill>
                   <a:srgbClr val="173343"/>
                 </a:solidFill>
@@ -8139,7 +9656,7 @@
               </a:defRPr>
             </a:lvl1pPr>
             <a:lvl2pPr>
-              <a:defRPr sz="2100" b="1">
+              <a:defRPr sz="2025" b="1">
                 <a:solidFill>
                   <a:srgbClr val="173343"/>
                 </a:solidFill>
@@ -8149,7 +9666,7 @@
               </a:defRPr>
             </a:lvl2pPr>
             <a:lvl3pPr>
-              <a:defRPr sz="2100" b="1">
+              <a:defRPr sz="2025" b="1">
                 <a:solidFill>
                   <a:srgbClr val="173343"/>
                 </a:solidFill>
@@ -8159,7 +9676,7 @@
               </a:defRPr>
             </a:lvl3pPr>
             <a:lvl4pPr>
-              <a:defRPr sz="2100" b="1">
+              <a:defRPr sz="2025" b="1">
                 <a:solidFill>
                   <a:srgbClr val="173343"/>
                 </a:solidFill>
@@ -8169,7 +9686,7 @@
               </a:defRPr>
             </a:lvl4pPr>
             <a:lvl5pPr>
-              <a:defRPr sz="2100" b="1">
+              <a:defRPr sz="2025" b="1">
                 <a:solidFill>
                   <a:srgbClr val="173343"/>
                 </a:solidFill>
@@ -8179,7 +9696,7 @@
               </a:defRPr>
             </a:lvl5pPr>
             <a:lvl6pPr>
-              <a:defRPr sz="2100" b="1">
+              <a:defRPr sz="2025" b="1">
                 <a:solidFill>
                   <a:srgbClr val="173343"/>
                 </a:solidFill>
@@ -8189,7 +9706,7 @@
               </a:defRPr>
             </a:lvl6pPr>
             <a:lvl7pPr>
-              <a:defRPr sz="2100" b="1">
+              <a:defRPr sz="2025" b="1">
                 <a:solidFill>
                   <a:srgbClr val="173343"/>
                 </a:solidFill>
@@ -8199,7 +9716,7 @@
               </a:defRPr>
             </a:lvl7pPr>
             <a:lvl8pPr>
-              <a:defRPr sz="2100" b="1">
+              <a:defRPr sz="2025" b="1">
                 <a:solidFill>
                   <a:srgbClr val="173343"/>
                 </a:solidFill>
@@ -8209,7 +9726,7 @@
               </a:defRPr>
             </a:lvl8pPr>
             <a:lvl9pPr>
-              <a:defRPr sz="2100" b="1">
+              <a:defRPr sz="2025" b="1">
                 <a:solidFill>
                   <a:srgbClr val="173343"/>
                 </a:solidFill>
@@ -8221,7 +9738,7 @@
           </a:lstStyle>
           <a:p xmlns:a="http://schemas.openxmlformats.org/drawingml/2006/main">
             <a:pPr>
-              <a:defRPr sz="2100" b="1">
+              <a:defRPr sz="2025" b="1">
                 <a:solidFill>
                   <a:srgbClr val="173343"/>
                 </a:solidFill>
@@ -8231,7 +9748,7 @@
               </a:defRPr>
             </a:pPr>
             <a:r>
-              <a:rPr sz="2100" b="1">
+              <a:rPr sz="2025" b="1">
                 <a:solidFill>
                   <a:srgbClr val="173343"/>
                 </a:solidFill>
@@ -8239,12 +9756,12 @@
                 <a:ea typeface="Apple SD Gothic Neo"/>
                 <a:cs typeface="Apple SD Gothic Neo"/>
               </a:rPr>
-              <a:t>fake TCP 13/13</a:t>
+              <a:t>CPU HTTP p50</a:t>
             </a:r>
           </a:p>
           <a:p xmlns:a="http://schemas.openxmlformats.org/drawingml/2006/main">
             <a:pPr>
-              <a:defRPr sz="2100" b="1">
+              <a:defRPr sz="2025" b="1">
                 <a:solidFill>
                   <a:srgbClr val="173343"/>
                 </a:solidFill>
@@ -8254,7 +9771,7 @@
               </a:defRPr>
             </a:pPr>
             <a:r>
-              <a:rPr sz="2100" b="1">
+              <a:rPr sz="2025" b="1">
                 <a:solidFill>
                   <a:srgbClr val="173343"/>
                 </a:solidFill>
@@ -8262,7 +9779,7 @@
                 <a:ea typeface="Apple SD Gothic Neo"/>
                 <a:cs typeface="Apple SD Gothic Neo"/>
               </a:rPr>
-              <a:t>Qwen TCP 11/13</a:t>
+              <a:t>12.50초 / 4.70초</a:t>
             </a:r>
           </a:p>
         </p:txBody>
@@ -8272,7 +9789,7 @@
           <p:cNvPr id="9" name="">
             <a:extLst xmlns:a="http://schemas.openxmlformats.org/drawingml/2006/main">
               <a:ext uri="{FF2B5EF4-FFF2-40B4-BE49-F238E27FC236}">
-                <a16:creationId xmlns:a16="http://schemas.microsoft.com/office/drawing/2014/main" id="{D76CCA5B-18C8-4CEB-8B1E-B5586D7142EB}"/>
+                <a16:creationId xmlns:a16="http://schemas.microsoft.com/office/drawing/2014/main" id="{325507C6-A594-4363-898E-7990E6D4BD5A}"/>
               </a:ext>
             </a:extLst>
           </p:cNvPr>
@@ -8283,8 +9800,8 @@
         </p:nvSpPr>
         <p:spPr>
           <a:xfrm xmlns:a="http://schemas.openxmlformats.org/drawingml/2006/main">
-            <a:off x="8134350" y="4791075"/>
-            <a:ext cx="3429000" cy="428625"/>
+            <a:off x="8134350" y="4648200"/>
+            <a:ext cx="3429000" cy="381000"/>
           </a:xfrm>
           <a:prstGeom xmlns:a="http://schemas.openxmlformats.org/drawingml/2006/main" prst="rect">
             <a:avLst/>
@@ -8298,9 +9815,9 @@
           <a:bodyPr xmlns:a="http://schemas.openxmlformats.org/drawingml/2006/main"/>
           <a:lstStyle xmlns:a="http://schemas.openxmlformats.org/drawingml/2006/main">
             <a:defPPr>
-              <a:defRPr sz="2025" b="1">
-                <a:solidFill>
-                  <a:srgbClr val="B25546"/>
+              <a:defRPr sz="1800" b="1">
+                <a:solidFill>
+                  <a:srgbClr val="087D69"/>
                 </a:solidFill>
                 <a:latin typeface="Apple SD Gothic Neo"/>
                 <a:ea typeface="Apple SD Gothic Neo"/>
@@ -8308,9 +9825,9 @@
               </a:defRPr>
             </a:defPPr>
             <a:lvl1pPr>
-              <a:defRPr sz="2025" b="1">
-                <a:solidFill>
-                  <a:srgbClr val="B25546"/>
+              <a:defRPr sz="1800" b="1">
+                <a:solidFill>
+                  <a:srgbClr val="087D69"/>
                 </a:solidFill>
                 <a:latin typeface="Apple SD Gothic Neo"/>
                 <a:ea typeface="Apple SD Gothic Neo"/>
@@ -8318,9 +9835,9 @@
               </a:defRPr>
             </a:lvl1pPr>
             <a:lvl2pPr>
-              <a:defRPr sz="2025" b="1">
-                <a:solidFill>
-                  <a:srgbClr val="B25546"/>
+              <a:defRPr sz="1800" b="1">
+                <a:solidFill>
+                  <a:srgbClr val="087D69"/>
                 </a:solidFill>
                 <a:latin typeface="Apple SD Gothic Neo"/>
                 <a:ea typeface="Apple SD Gothic Neo"/>
@@ -8328,9 +9845,9 @@
               </a:defRPr>
             </a:lvl2pPr>
             <a:lvl3pPr>
-              <a:defRPr sz="2025" b="1">
-                <a:solidFill>
-                  <a:srgbClr val="B25546"/>
+              <a:defRPr sz="1800" b="1">
+                <a:solidFill>
+                  <a:srgbClr val="087D69"/>
                 </a:solidFill>
                 <a:latin typeface="Apple SD Gothic Neo"/>
                 <a:ea typeface="Apple SD Gothic Neo"/>
@@ -8338,9 +9855,9 @@
               </a:defRPr>
             </a:lvl3pPr>
             <a:lvl4pPr>
-              <a:defRPr sz="2025" b="1">
-                <a:solidFill>
-                  <a:srgbClr val="B25546"/>
+              <a:defRPr sz="1800" b="1">
+                <a:solidFill>
+                  <a:srgbClr val="087D69"/>
                 </a:solidFill>
                 <a:latin typeface="Apple SD Gothic Neo"/>
                 <a:ea typeface="Apple SD Gothic Neo"/>
@@ -8348,9 +9865,9 @@
               </a:defRPr>
             </a:lvl4pPr>
             <a:lvl5pPr>
-              <a:defRPr sz="2025" b="1">
-                <a:solidFill>
-                  <a:srgbClr val="B25546"/>
+              <a:defRPr sz="1800" b="1">
+                <a:solidFill>
+                  <a:srgbClr val="087D69"/>
                 </a:solidFill>
                 <a:latin typeface="Apple SD Gothic Neo"/>
                 <a:ea typeface="Apple SD Gothic Neo"/>
@@ -8358,9 +9875,9 @@
               </a:defRPr>
             </a:lvl5pPr>
             <a:lvl6pPr>
-              <a:defRPr sz="2025" b="1">
-                <a:solidFill>
-                  <a:srgbClr val="B25546"/>
+              <a:defRPr sz="1800" b="1">
+                <a:solidFill>
+                  <a:srgbClr val="087D69"/>
                 </a:solidFill>
                 <a:latin typeface="Apple SD Gothic Neo"/>
                 <a:ea typeface="Apple SD Gothic Neo"/>
@@ -8368,9 +9885,9 @@
               </a:defRPr>
             </a:lvl6pPr>
             <a:lvl7pPr>
-              <a:defRPr sz="2025" b="1">
-                <a:solidFill>
-                  <a:srgbClr val="B25546"/>
+              <a:defRPr sz="1800" b="1">
+                <a:solidFill>
+                  <a:srgbClr val="087D69"/>
                 </a:solidFill>
                 <a:latin typeface="Apple SD Gothic Neo"/>
                 <a:ea typeface="Apple SD Gothic Neo"/>
@@ -8378,9 +9895,9 @@
               </a:defRPr>
             </a:lvl7pPr>
             <a:lvl8pPr>
-              <a:defRPr sz="2025" b="1">
-                <a:solidFill>
-                  <a:srgbClr val="B25546"/>
+              <a:defRPr sz="1800" b="1">
+                <a:solidFill>
+                  <a:srgbClr val="087D69"/>
                 </a:solidFill>
                 <a:latin typeface="Apple SD Gothic Neo"/>
                 <a:ea typeface="Apple SD Gothic Neo"/>
@@ -8388,9 +9905,9 @@
               </a:defRPr>
             </a:lvl8pPr>
             <a:lvl9pPr>
-              <a:defRPr sz="2025" b="1">
-                <a:solidFill>
-                  <a:srgbClr val="B25546"/>
+              <a:defRPr sz="1800" b="1">
+                <a:solidFill>
+                  <a:srgbClr val="087D69"/>
                 </a:solidFill>
                 <a:latin typeface="Apple SD Gothic Neo"/>
                 <a:ea typeface="Apple SD Gothic Neo"/>
@@ -8400,9 +9917,9 @@
           </a:lstStyle>
           <a:p xmlns:a="http://schemas.openxmlformats.org/drawingml/2006/main">
             <a:pPr>
-              <a:defRPr sz="2025" b="1">
-                <a:solidFill>
-                  <a:srgbClr val="B25546"/>
+              <a:defRPr sz="1800" b="1">
+                <a:solidFill>
+                  <a:srgbClr val="087D69"/>
                 </a:solidFill>
                 <a:latin typeface="Apple SD Gothic Neo"/>
                 <a:ea typeface="Apple SD Gothic Neo"/>
@@ -8410,15 +9927,15 @@
               </a:defRPr>
             </a:pPr>
             <a:r>
-              <a:rPr sz="2025" b="1">
-                <a:solidFill>
-                  <a:srgbClr val="B25546"/>
+              <a:rPr sz="1800" b="1">
+                <a:solidFill>
+                  <a:srgbClr val="087D69"/>
                 </a:solidFill>
                 <a:latin typeface="Apple SD Gothic Neo"/>
                 <a:ea typeface="Apple SD Gothic Neo"/>
                 <a:cs typeface="Apple SD Gothic Neo"/>
               </a:rPr>
-              <a:t>새 기억 2건 실패</a:t>
+              <a:t>이름 회상 0/10 · 10/10</a:t>
             </a:r>
           </a:p>
         </p:txBody>
@@ -8428,7 +9945,163 @@
           <p:cNvPr id="10" name="">
             <a:extLst xmlns:a="http://schemas.openxmlformats.org/drawingml/2006/main">
               <a:ext uri="{FF2B5EF4-FFF2-40B4-BE49-F238E27FC236}">
-                <a16:creationId xmlns:a16="http://schemas.microsoft.com/office/drawing/2014/main" id="{05A0A73E-F3BA-4C02-B177-B99CC054A347}"/>
+                <a16:creationId xmlns:a16="http://schemas.microsoft.com/office/drawing/2014/main" id="{5664106A-0671-4C6E-8D1D-06EC445D9889}"/>
+              </a:ext>
+            </a:extLst>
+          </p:cNvPr>
+          <p:cNvSpPr>
+            <a:spLocks xmlns:a="http://schemas.openxmlformats.org/drawingml/2006/main" noGrp="1"/>
+          </p:cNvSpPr>
+          <p:nvPr/>
+        </p:nvSpPr>
+        <p:spPr>
+          <a:xfrm xmlns:a="http://schemas.openxmlformats.org/drawingml/2006/main">
+            <a:off x="8134350" y="5143500"/>
+            <a:ext cx="3429000" cy="342900"/>
+          </a:xfrm>
+          <a:prstGeom xmlns:a="http://schemas.openxmlformats.org/drawingml/2006/main" prst="rect">
+            <a:avLst/>
+          </a:prstGeom>
+          <a:noFill xmlns:a="http://schemas.openxmlformats.org/drawingml/2006/main"/>
+          <a:ln xmlns:a="http://schemas.openxmlformats.org/drawingml/2006/main" w="0">
+            <a:noFill/>
+          </a:ln>
+        </p:spPr>
+        <p:txBody>
+          <a:bodyPr xmlns:a="http://schemas.openxmlformats.org/drawingml/2006/main"/>
+          <a:lstStyle xmlns:a="http://schemas.openxmlformats.org/drawingml/2006/main">
+            <a:defPPr>
+              <a:defRPr sz="1575" b="0">
+                <a:solidFill>
+                  <a:srgbClr val="526A77"/>
+                </a:solidFill>
+                <a:latin typeface="Apple SD Gothic Neo"/>
+                <a:ea typeface="Apple SD Gothic Neo"/>
+                <a:cs typeface="Apple SD Gothic Neo"/>
+              </a:defRPr>
+            </a:defPPr>
+            <a:lvl1pPr>
+              <a:defRPr sz="1575" b="0">
+                <a:solidFill>
+                  <a:srgbClr val="526A77"/>
+                </a:solidFill>
+                <a:latin typeface="Apple SD Gothic Neo"/>
+                <a:ea typeface="Apple SD Gothic Neo"/>
+                <a:cs typeface="Apple SD Gothic Neo"/>
+              </a:defRPr>
+            </a:lvl1pPr>
+            <a:lvl2pPr>
+              <a:defRPr sz="1575" b="0">
+                <a:solidFill>
+                  <a:srgbClr val="526A77"/>
+                </a:solidFill>
+                <a:latin typeface="Apple SD Gothic Neo"/>
+                <a:ea typeface="Apple SD Gothic Neo"/>
+                <a:cs typeface="Apple SD Gothic Neo"/>
+              </a:defRPr>
+            </a:lvl2pPr>
+            <a:lvl3pPr>
+              <a:defRPr sz="1575" b="0">
+                <a:solidFill>
+                  <a:srgbClr val="526A77"/>
+                </a:solidFill>
+                <a:latin typeface="Apple SD Gothic Neo"/>
+                <a:ea typeface="Apple SD Gothic Neo"/>
+                <a:cs typeface="Apple SD Gothic Neo"/>
+              </a:defRPr>
+            </a:lvl3pPr>
+            <a:lvl4pPr>
+              <a:defRPr sz="1575" b="0">
+                <a:solidFill>
+                  <a:srgbClr val="526A77"/>
+                </a:solidFill>
+                <a:latin typeface="Apple SD Gothic Neo"/>
+                <a:ea typeface="Apple SD Gothic Neo"/>
+                <a:cs typeface="Apple SD Gothic Neo"/>
+              </a:defRPr>
+            </a:lvl4pPr>
+            <a:lvl5pPr>
+              <a:defRPr sz="1575" b="0">
+                <a:solidFill>
+                  <a:srgbClr val="526A77"/>
+                </a:solidFill>
+                <a:latin typeface="Apple SD Gothic Neo"/>
+                <a:ea typeface="Apple SD Gothic Neo"/>
+                <a:cs typeface="Apple SD Gothic Neo"/>
+              </a:defRPr>
+            </a:lvl5pPr>
+            <a:lvl6pPr>
+              <a:defRPr sz="1575" b="0">
+                <a:solidFill>
+                  <a:srgbClr val="526A77"/>
+                </a:solidFill>
+                <a:latin typeface="Apple SD Gothic Neo"/>
+                <a:ea typeface="Apple SD Gothic Neo"/>
+                <a:cs typeface="Apple SD Gothic Neo"/>
+              </a:defRPr>
+            </a:lvl6pPr>
+            <a:lvl7pPr>
+              <a:defRPr sz="1575" b="0">
+                <a:solidFill>
+                  <a:srgbClr val="526A77"/>
+                </a:solidFill>
+                <a:latin typeface="Apple SD Gothic Neo"/>
+                <a:ea typeface="Apple SD Gothic Neo"/>
+                <a:cs typeface="Apple SD Gothic Neo"/>
+              </a:defRPr>
+            </a:lvl7pPr>
+            <a:lvl8pPr>
+              <a:defRPr sz="1575" b="0">
+                <a:solidFill>
+                  <a:srgbClr val="526A77"/>
+                </a:solidFill>
+                <a:latin typeface="Apple SD Gothic Neo"/>
+                <a:ea typeface="Apple SD Gothic Neo"/>
+                <a:cs typeface="Apple SD Gothic Neo"/>
+              </a:defRPr>
+            </a:lvl8pPr>
+            <a:lvl9pPr>
+              <a:defRPr sz="1575" b="0">
+                <a:solidFill>
+                  <a:srgbClr val="526A77"/>
+                </a:solidFill>
+                <a:latin typeface="Apple SD Gothic Neo"/>
+                <a:ea typeface="Apple SD Gothic Neo"/>
+                <a:cs typeface="Apple SD Gothic Neo"/>
+              </a:defRPr>
+            </a:lvl9pPr>
+          </a:lstStyle>
+          <a:p xmlns:a="http://schemas.openxmlformats.org/drawingml/2006/main">
+            <a:pPr>
+              <a:defRPr sz="1575" b="0">
+                <a:solidFill>
+                  <a:srgbClr val="526A77"/>
+                </a:solidFill>
+                <a:latin typeface="Apple SD Gothic Neo"/>
+                <a:ea typeface="Apple SD Gothic Neo"/>
+                <a:cs typeface="Apple SD Gothic Neo"/>
+              </a:defRPr>
+            </a:pPr>
+            <a:r>
+              <a:rPr sz="1575" b="0">
+                <a:solidFill>
+                  <a:srgbClr val="526A77"/>
+                </a:solidFill>
+                <a:latin typeface="Apple SD Gothic Neo"/>
+                <a:ea typeface="Apple SD Gothic Neo"/>
+                <a:cs typeface="Apple SD Gothic Neo"/>
+              </a:rPr>
+              <a:t>Qwen / OpenAI 순서</a:t>
+            </a:r>
+          </a:p>
+        </p:txBody>
+      </p:sp>
+      <p:sp>
+        <p:nvSpPr>
+          <p:cNvPr id="11" name="">
+            <a:extLst xmlns:a="http://schemas.openxmlformats.org/drawingml/2006/main">
+              <a:ext uri="{FF2B5EF4-FFF2-40B4-BE49-F238E27FC236}">
+                <a16:creationId xmlns:a16="http://schemas.microsoft.com/office/drawing/2014/main" id="{0015F8B9-9615-450E-B21E-E97C177AF172}"/>
               </a:ext>
             </a:extLst>
           </p:cNvPr>
@@ -8574,7 +10247,7 @@
                 <a:ea typeface="Apple SD Gothic Neo"/>
                 <a:cs typeface="Apple SD Gothic Neo"/>
               </a:rPr>
-              <a:t>207 PASS·13 XFAIL / 공개 단위 110 PASS·5 XFAIL. 화면 근거는 합성이고 조치는 미실행 권고입니다.</a:t>
+              <a:t>지연: 조건당 n=5. 회상: 한 이력의 반복. OpenAI 통합 13/13. 왼쪽은 Qwen 실제 화면입니다.</a:t>
             </a:r>
           </a:p>
         </p:txBody>
@@ -8582,7 +10255,7 @@
     </p:spTree>
     <p:extLst>
       <p:ext uri="{BB962C8B-B14F-4D97-AF65-F5344CB8AC3E}">
-        <p14:creationId xmlns:p14="http://schemas.microsoft.com/office/powerpoint/2010/main" val="913014458"/>
+        <p14:creationId xmlns:p14="http://schemas.microsoft.com/office/powerpoint/2010/main" val="1648244370"/>
       </p:ext>
     </p:extLst>
   </p:cSld>
@@ -8613,7 +10286,7 @@
           <p:cNvPr id="11" name="">
             <a:extLst xmlns:a="http://schemas.openxmlformats.org/drawingml/2006/main">
               <a:ext uri="{FF2B5EF4-FFF2-40B4-BE49-F238E27FC236}">
-                <a16:creationId xmlns:a16="http://schemas.microsoft.com/office/drawing/2014/main" id="{371C7A9B-65BC-4D1E-B135-E72A4431C5ED}"/>
+                <a16:creationId xmlns:a16="http://schemas.microsoft.com/office/drawing/2014/main" id="{63540493-C06E-43AB-92D1-FE4DB6B26BA7}"/>
               </a:ext>
             </a:extLst>
           </p:cNvPr>
@@ -8769,7 +10442,7 @@
           <p:cNvPr id="2" name="">
             <a:extLst xmlns:a="http://schemas.openxmlformats.org/drawingml/2006/main">
               <a:ext uri="{FF2B5EF4-FFF2-40B4-BE49-F238E27FC236}">
-                <a16:creationId xmlns:a16="http://schemas.microsoft.com/office/drawing/2014/main" id="{A8FAF512-94C3-4717-BD40-EA884C25CF20}"/>
+                <a16:creationId xmlns:a16="http://schemas.microsoft.com/office/drawing/2014/main" id="{1D63F595-0813-4133-9F00-EC56EE7CD818}"/>
               </a:ext>
             </a:extLst>
           </p:cNvPr>
@@ -8925,7 +10598,7 @@
           <p:cNvPr id="3" name="">
             <a:extLst xmlns:a="http://schemas.openxmlformats.org/drawingml/2006/main">
               <a:ext uri="{FF2B5EF4-FFF2-40B4-BE49-F238E27FC236}">
-                <a16:creationId xmlns:a16="http://schemas.microsoft.com/office/drawing/2014/main" id="{B4A8EBD1-CE7D-4B57-AB1D-04475D40FE7A}"/>
+                <a16:creationId xmlns:a16="http://schemas.microsoft.com/office/drawing/2014/main" id="{18BD1239-9E8A-41AB-B384-E7F55EFE9DBD}"/>
               </a:ext>
             </a:extLst>
           </p:cNvPr>
@@ -9081,7 +10754,7 @@
           <p:cNvPr id="4" name="">
             <a:extLst xmlns:a="http://schemas.openxmlformats.org/drawingml/2006/main">
               <a:ext uri="{FF2B5EF4-FFF2-40B4-BE49-F238E27FC236}">
-                <a16:creationId xmlns:a16="http://schemas.microsoft.com/office/drawing/2014/main" id="{F12AB7B8-2F70-4856-A3C4-2BED7AD48879}"/>
+                <a16:creationId xmlns:a16="http://schemas.microsoft.com/office/drawing/2014/main" id="{B04799F7-5341-41E5-B610-5DDCEF6AF4F8}"/>
               </a:ext>
             </a:extLst>
           </p:cNvPr>
@@ -9237,7 +10910,7 @@
           <p:cNvPr id="5" name="">
             <a:extLst xmlns:a="http://schemas.openxmlformats.org/drawingml/2006/main">
               <a:ext uri="{FF2B5EF4-FFF2-40B4-BE49-F238E27FC236}">
-                <a16:creationId xmlns:a16="http://schemas.microsoft.com/office/drawing/2014/main" id="{43475ABC-BD5F-402D-9E00-DB38FE7A80C7}"/>
+                <a16:creationId xmlns:a16="http://schemas.microsoft.com/office/drawing/2014/main" id="{19D17EC0-14E0-491D-81EF-B4AECAF7335F}"/>
               </a:ext>
             </a:extLst>
           </p:cNvPr>
@@ -9393,7 +11066,7 @@
           <p:cNvPr id="6" name="">
             <a:extLst xmlns:a="http://schemas.openxmlformats.org/drawingml/2006/main">
               <a:ext uri="{FF2B5EF4-FFF2-40B4-BE49-F238E27FC236}">
-                <a16:creationId xmlns:a16="http://schemas.microsoft.com/office/drawing/2014/main" id="{D26B3EF8-8BBA-4D1E-A86D-842E10DC5821}"/>
+                <a16:creationId xmlns:a16="http://schemas.microsoft.com/office/drawing/2014/main" id="{81FB5AB8-E0A5-4925-AD2B-8CBD9ACAAA8C}"/>
               </a:ext>
             </a:extLst>
           </p:cNvPr>
@@ -9641,7 +11314,7 @@
           <p:cNvPr id="7" name="">
             <a:extLst xmlns:a="http://schemas.openxmlformats.org/drawingml/2006/main">
               <a:ext uri="{FF2B5EF4-FFF2-40B4-BE49-F238E27FC236}">
-                <a16:creationId xmlns:a16="http://schemas.microsoft.com/office/drawing/2014/main" id="{23A094C9-8144-4E15-8345-757542CAB92A}"/>
+                <a16:creationId xmlns:a16="http://schemas.microsoft.com/office/drawing/2014/main" id="{CECAA1FB-633A-4771-BF33-C87712DD5629}"/>
               </a:ext>
             </a:extLst>
           </p:cNvPr>
@@ -9797,7 +11470,7 @@
           <p:cNvPr id="8" name="">
             <a:extLst xmlns:a="http://schemas.openxmlformats.org/drawingml/2006/main">
               <a:ext uri="{FF2B5EF4-FFF2-40B4-BE49-F238E27FC236}">
-                <a16:creationId xmlns:a16="http://schemas.microsoft.com/office/drawing/2014/main" id="{C7686EE0-10A9-43BF-A988-D8865204825E}"/>
+                <a16:creationId xmlns:a16="http://schemas.microsoft.com/office/drawing/2014/main" id="{C5042DAB-BC9F-4FFB-AE8C-84CE0DAE2143}"/>
               </a:ext>
             </a:extLst>
           </p:cNvPr>
@@ -9953,7 +11626,7 @@
           <p:cNvPr id="9" name="">
             <a:extLst xmlns:a="http://schemas.openxmlformats.org/drawingml/2006/main">
               <a:ext uri="{FF2B5EF4-FFF2-40B4-BE49-F238E27FC236}">
-                <a16:creationId xmlns:a16="http://schemas.microsoft.com/office/drawing/2014/main" id="{C10D5C3D-07FE-4BE4-9EB3-1BEA5ADE4AA8}"/>
+                <a16:creationId xmlns:a16="http://schemas.microsoft.com/office/drawing/2014/main" id="{3B4671F1-E34F-4658-A277-7E56D0ED77DF}"/>
               </a:ext>
             </a:extLst>
           </p:cNvPr>
@@ -10109,7 +11782,7 @@
           <p:cNvPr id="10" name="">
             <a:extLst xmlns:a="http://schemas.openxmlformats.org/drawingml/2006/main">
               <a:ext uri="{FF2B5EF4-FFF2-40B4-BE49-F238E27FC236}">
-                <a16:creationId xmlns:a16="http://schemas.microsoft.com/office/drawing/2014/main" id="{526BC035-1CA5-4EF9-BD87-54DF345D5608}"/>
+                <a16:creationId xmlns:a16="http://schemas.microsoft.com/office/drawing/2014/main" id="{C5FDBFEC-4A94-40D4-B420-F8C8C2CB01B9}"/>
               </a:ext>
             </a:extLst>
           </p:cNvPr>
@@ -10263,7 +11936,7 @@
     </p:spTree>
     <p:extLst>
       <p:ext uri="{BB962C8B-B14F-4D97-AF65-F5344CB8AC3E}">
-        <p14:creationId xmlns:p14="http://schemas.microsoft.com/office/powerpoint/2010/main" val="161781251"/>
+        <p14:creationId xmlns:p14="http://schemas.microsoft.com/office/powerpoint/2010/main" val="348392173"/>
       </p:ext>
     </p:extLst>
   </p:cSld>
@@ -10294,7 +11967,7 @@
           <p:cNvPr id="10" name="">
             <a:extLst xmlns:a="http://schemas.openxmlformats.org/drawingml/2006/main">
               <a:ext uri="{FF2B5EF4-FFF2-40B4-BE49-F238E27FC236}">
-                <a16:creationId xmlns:a16="http://schemas.microsoft.com/office/drawing/2014/main" id="{748C005B-C4CC-44D7-9DAA-89E7E1528113}"/>
+                <a16:creationId xmlns:a16="http://schemas.microsoft.com/office/drawing/2014/main" id="{E6A5A2CB-28BE-4FB7-85DF-9E19EB401775}"/>
               </a:ext>
             </a:extLst>
           </p:cNvPr>
@@ -10450,7 +12123,7 @@
           <p:cNvPr id="2" name="">
             <a:extLst xmlns:a="http://schemas.openxmlformats.org/drawingml/2006/main">
               <a:ext uri="{FF2B5EF4-FFF2-40B4-BE49-F238E27FC236}">
-                <a16:creationId xmlns:a16="http://schemas.microsoft.com/office/drawing/2014/main" id="{329ECE39-773F-4A3D-A0A9-A49D0C873935}"/>
+                <a16:creationId xmlns:a16="http://schemas.microsoft.com/office/drawing/2014/main" id="{15A33E45-5273-4359-9715-07E8828B7889}"/>
               </a:ext>
             </a:extLst>
           </p:cNvPr>
@@ -10606,7 +12279,7 @@
           <p:cNvPr id="3" name="">
             <a:extLst xmlns:a="http://schemas.openxmlformats.org/drawingml/2006/main">
               <a:ext uri="{FF2B5EF4-FFF2-40B4-BE49-F238E27FC236}">
-                <a16:creationId xmlns:a16="http://schemas.microsoft.com/office/drawing/2014/main" id="{E1F93136-E3A3-47CE-BD4A-4AF492039B71}"/>
+                <a16:creationId xmlns:a16="http://schemas.microsoft.com/office/drawing/2014/main" id="{1C0AB6EC-DD20-4D72-A81A-B5BF7246A561}"/>
               </a:ext>
             </a:extLst>
           </p:cNvPr>
@@ -10762,7 +12435,7 @@
           <p:cNvPr id="4" name="">
             <a:extLst xmlns:a="http://schemas.openxmlformats.org/drawingml/2006/main">
               <a:ext uri="{FF2B5EF4-FFF2-40B4-BE49-F238E27FC236}">
-                <a16:creationId xmlns:a16="http://schemas.microsoft.com/office/drawing/2014/main" id="{5CEC010D-BF8B-4576-BDE5-4D7FF2B22168}"/>
+                <a16:creationId xmlns:a16="http://schemas.microsoft.com/office/drawing/2014/main" id="{926D4F43-8DD1-4D86-82FF-6616AE919351}"/>
               </a:ext>
             </a:extLst>
           </p:cNvPr>
@@ -10918,7 +12591,7 @@
           <p:cNvPr id="5" name="">
             <a:extLst xmlns:a="http://schemas.openxmlformats.org/drawingml/2006/main">
               <a:ext uri="{FF2B5EF4-FFF2-40B4-BE49-F238E27FC236}">
-                <a16:creationId xmlns:a16="http://schemas.microsoft.com/office/drawing/2014/main" id="{80A1F08E-CDBB-44B2-AED5-444CFB6B45A0}"/>
+                <a16:creationId xmlns:a16="http://schemas.microsoft.com/office/drawing/2014/main" id="{9E1876F6-7F9D-4FA1-8DC8-AD0F977AFC3A}"/>
               </a:ext>
             </a:extLst>
           </p:cNvPr>
@@ -11074,7 +12747,7 @@
           <p:cNvPr id="6" name="">
             <a:extLst xmlns:a="http://schemas.openxmlformats.org/drawingml/2006/main">
               <a:ext uri="{FF2B5EF4-FFF2-40B4-BE49-F238E27FC236}">
-                <a16:creationId xmlns:a16="http://schemas.microsoft.com/office/drawing/2014/main" id="{952A4743-E3EC-412A-B3D2-7F007620B90C}"/>
+                <a16:creationId xmlns:a16="http://schemas.microsoft.com/office/drawing/2014/main" id="{00ED4C37-ADDB-4C2D-97B6-148B5A164078}"/>
               </a:ext>
             </a:extLst>
           </p:cNvPr>
@@ -11253,7 +12926,7 @@
           <p:cNvPr id="7" name="">
             <a:extLst xmlns:a="http://schemas.openxmlformats.org/drawingml/2006/main">
               <a:ext uri="{FF2B5EF4-FFF2-40B4-BE49-F238E27FC236}">
-                <a16:creationId xmlns:a16="http://schemas.microsoft.com/office/drawing/2014/main" id="{63717EDF-81C5-4933-AAFF-E870A87351C8}"/>
+                <a16:creationId xmlns:a16="http://schemas.microsoft.com/office/drawing/2014/main" id="{D93AEB36-438C-4736-8F60-7C7C1F85A4D7}"/>
               </a:ext>
             </a:extLst>
           </p:cNvPr>
@@ -11409,7 +13082,7 @@
           <p:cNvPr id="8" name="">
             <a:extLst xmlns:a="http://schemas.openxmlformats.org/drawingml/2006/main">
               <a:ext uri="{FF2B5EF4-FFF2-40B4-BE49-F238E27FC236}">
-                <a16:creationId xmlns:a16="http://schemas.microsoft.com/office/drawing/2014/main" id="{AF7D6E8F-A043-4AE0-B2D5-18A10662D269}"/>
+                <a16:creationId xmlns:a16="http://schemas.microsoft.com/office/drawing/2014/main" id="{46AA9CF1-1AE8-4B11-B1D9-6F168E6ACC70}"/>
               </a:ext>
             </a:extLst>
           </p:cNvPr>
@@ -11634,7 +13307,7 @@
           <p:cNvPr id="9" name="">
             <a:extLst xmlns:a="http://schemas.openxmlformats.org/drawingml/2006/main">
               <a:ext uri="{FF2B5EF4-FFF2-40B4-BE49-F238E27FC236}">
-                <a16:creationId xmlns:a16="http://schemas.microsoft.com/office/drawing/2014/main" id="{C046F74D-37F6-4389-8372-EE3C6649E94E}"/>
+                <a16:creationId xmlns:a16="http://schemas.microsoft.com/office/drawing/2014/main" id="{E50349B1-F833-4FD4-B961-53ACDC8B50F0}"/>
               </a:ext>
             </a:extLst>
           </p:cNvPr>
@@ -11788,7 +13461,7 @@
     </p:spTree>
     <p:extLst>
       <p:ext uri="{BB962C8B-B14F-4D97-AF65-F5344CB8AC3E}">
-        <p14:creationId xmlns:p14="http://schemas.microsoft.com/office/powerpoint/2010/main" val="2050408842"/>
+        <p14:creationId xmlns:p14="http://schemas.microsoft.com/office/powerpoint/2010/main" val="1691600419"/>
       </p:ext>
     </p:extLst>
   </p:cSld>
@@ -11819,7 +13492,7 @@
           <p:cNvPr id="11" name="">
             <a:extLst xmlns:a="http://schemas.openxmlformats.org/drawingml/2006/main">
               <a:ext uri="{FF2B5EF4-FFF2-40B4-BE49-F238E27FC236}">
-                <a16:creationId xmlns:a16="http://schemas.microsoft.com/office/drawing/2014/main" id="{95CA2C50-D7AE-4F96-B05C-DBEC51852A05}"/>
+                <a16:creationId xmlns:a16="http://schemas.microsoft.com/office/drawing/2014/main" id="{3AFA447E-86FE-43B0-BE79-D448E695399F}"/>
               </a:ext>
             </a:extLst>
           </p:cNvPr>
@@ -11975,7 +13648,7 @@
           <p:cNvPr id="2" name="">
             <a:extLst xmlns:a="http://schemas.openxmlformats.org/drawingml/2006/main">
               <a:ext uri="{FF2B5EF4-FFF2-40B4-BE49-F238E27FC236}">
-                <a16:creationId xmlns:a16="http://schemas.microsoft.com/office/drawing/2014/main" id="{D872D40E-93A2-4102-8ABE-DEA02DBBD156}"/>
+                <a16:creationId xmlns:a16="http://schemas.microsoft.com/office/drawing/2014/main" id="{8257B63B-217D-424C-8CDA-178BDBF99CF0}"/>
               </a:ext>
             </a:extLst>
           </p:cNvPr>
@@ -12131,7 +13804,7 @@
           <p:cNvPr id="3" name="">
             <a:extLst xmlns:a="http://schemas.openxmlformats.org/drawingml/2006/main">
               <a:ext uri="{FF2B5EF4-FFF2-40B4-BE49-F238E27FC236}">
-                <a16:creationId xmlns:a16="http://schemas.microsoft.com/office/drawing/2014/main" id="{23E1E759-A092-41A8-B6B9-B38969044E0C}"/>
+                <a16:creationId xmlns:a16="http://schemas.microsoft.com/office/drawing/2014/main" id="{70196BBE-24C0-4FAA-BE4D-BDE73673E0D8}"/>
               </a:ext>
             </a:extLst>
           </p:cNvPr>
@@ -12287,7 +13960,7 @@
           <p:cNvPr id="4" name="">
             <a:extLst xmlns:a="http://schemas.openxmlformats.org/drawingml/2006/main">
               <a:ext uri="{FF2B5EF4-FFF2-40B4-BE49-F238E27FC236}">
-                <a16:creationId xmlns:a16="http://schemas.microsoft.com/office/drawing/2014/main" id="{DDF62E1F-DB79-44F1-BADD-67EE99F38E5E}"/>
+                <a16:creationId xmlns:a16="http://schemas.microsoft.com/office/drawing/2014/main" id="{A7B2C3F9-1966-429F-91CB-B9F31A676FD8}"/>
               </a:ext>
             </a:extLst>
           </p:cNvPr>
@@ -12443,7 +14116,7 @@
           <p:cNvPr id="5" name="">
             <a:extLst xmlns:a="http://schemas.openxmlformats.org/drawingml/2006/main">
               <a:ext uri="{FF2B5EF4-FFF2-40B4-BE49-F238E27FC236}">
-                <a16:creationId xmlns:a16="http://schemas.microsoft.com/office/drawing/2014/main" id="{EB3E99A0-6BA1-4191-A649-2CB40A67EA4F}"/>
+                <a16:creationId xmlns:a16="http://schemas.microsoft.com/office/drawing/2014/main" id="{2DCF087A-94F6-45AF-B34A-0B22B43530C7}"/>
               </a:ext>
             </a:extLst>
           </p:cNvPr>
@@ -12599,7 +14272,7 @@
           <p:cNvPr id="6" name="">
             <a:extLst xmlns:a="http://schemas.openxmlformats.org/drawingml/2006/main">
               <a:ext uri="{FF2B5EF4-FFF2-40B4-BE49-F238E27FC236}">
-                <a16:creationId xmlns:a16="http://schemas.microsoft.com/office/drawing/2014/main" id="{AF49EB36-CAF4-4540-8E94-9BF12EC3584B}"/>
+                <a16:creationId xmlns:a16="http://schemas.microsoft.com/office/drawing/2014/main" id="{3E918099-5697-4ED8-AF60-65A452E66B10}"/>
               </a:ext>
             </a:extLst>
           </p:cNvPr>
@@ -12824,7 +14497,7 @@
           <p:cNvPr id="7" name="">
             <a:extLst xmlns:a="http://schemas.openxmlformats.org/drawingml/2006/main">
               <a:ext uri="{FF2B5EF4-FFF2-40B4-BE49-F238E27FC236}">
-                <a16:creationId xmlns:a16="http://schemas.microsoft.com/office/drawing/2014/main" id="{C001567D-A5D9-4423-A249-6FA115A8FCED}"/>
+                <a16:creationId xmlns:a16="http://schemas.microsoft.com/office/drawing/2014/main" id="{6A09ECBF-A7A0-44F8-BC3C-C50265FC27B5}"/>
               </a:ext>
             </a:extLst>
           </p:cNvPr>
@@ -12980,7 +14653,7 @@
           <p:cNvPr id="8" name="">
             <a:extLst xmlns:a="http://schemas.openxmlformats.org/drawingml/2006/main">
               <a:ext uri="{FF2B5EF4-FFF2-40B4-BE49-F238E27FC236}">
-                <a16:creationId xmlns:a16="http://schemas.microsoft.com/office/drawing/2014/main" id="{8CB17F39-F926-4685-B31B-CF3027623192}"/>
+                <a16:creationId xmlns:a16="http://schemas.microsoft.com/office/drawing/2014/main" id="{759DCAF9-CBF9-4F7F-9016-67B621498FF5}"/>
               </a:ext>
             </a:extLst>
           </p:cNvPr>
@@ -13136,7 +14809,7 @@
           <p:cNvPr id="9" name="">
             <a:extLst xmlns:a="http://schemas.openxmlformats.org/drawingml/2006/main">
               <a:ext uri="{FF2B5EF4-FFF2-40B4-BE49-F238E27FC236}">
-                <a16:creationId xmlns:a16="http://schemas.microsoft.com/office/drawing/2014/main" id="{E8763AF4-5D3E-4BE7-8244-77E182C66EA8}"/>
+                <a16:creationId xmlns:a16="http://schemas.microsoft.com/office/drawing/2014/main" id="{DEC9B916-E3D1-475A-924D-192A59C38D66}"/>
               </a:ext>
             </a:extLst>
           </p:cNvPr>
@@ -13292,7 +14965,7 @@
           <p:cNvPr id="10" name="">
             <a:extLst xmlns:a="http://schemas.openxmlformats.org/drawingml/2006/main">
               <a:ext uri="{FF2B5EF4-FFF2-40B4-BE49-F238E27FC236}">
-                <a16:creationId xmlns:a16="http://schemas.microsoft.com/office/drawing/2014/main" id="{8FBD2D09-E097-4F47-B05B-EB5E2E548F08}"/>
+                <a16:creationId xmlns:a16="http://schemas.microsoft.com/office/drawing/2014/main" id="{6D5B49B9-66DE-46F9-ACB3-629D5A496ABD}"/>
               </a:ext>
             </a:extLst>
           </p:cNvPr>
@@ -13438,7 +15111,7 @@
                 <a:ea typeface="Apple SD Gothic Neo"/>
                 <a:cs typeface="Apple SD Gothic Neo"/>
               </a:rPr>
-              <a:t>런북이 부족할 때만 호출합니다. 작은 런북 6종·요약 의미 손실은 남은 한계이며 독립 모델 검증이 다음 과제입니다.</a:t>
+              <a:t>런북이 부족할 때만 호출합니다. 런북 6종·기억 실패는 남은 한계입니다. OpenAI 교차 검증을 마쳤고 실제 로그·평가 집합 확대가 다음 과제입니다.</a:t>
             </a:r>
           </a:p>
         </p:txBody>
@@ -13446,7 +15119,7 @@
     </p:spTree>
     <p:extLst>
       <p:ext uri="{BB962C8B-B14F-4D97-AF65-F5344CB8AC3E}">
-        <p14:creationId xmlns:p14="http://schemas.microsoft.com/office/powerpoint/2010/main" val="1295135356"/>
+        <p14:creationId xmlns:p14="http://schemas.microsoft.com/office/powerpoint/2010/main" val="152908274"/>
       </p:ext>
     </p:extLst>
   </p:cSld>
@@ -13477,7 +15150,7 @@
           <p:cNvPr id="7" name="">
             <a:extLst xmlns:a="http://schemas.openxmlformats.org/drawingml/2006/main">
               <a:ext uri="{FF2B5EF4-FFF2-40B4-BE49-F238E27FC236}">
-                <a16:creationId xmlns:a16="http://schemas.microsoft.com/office/drawing/2014/main" id="{DA367ADC-6220-4D7A-BBFC-73840D7D2A2D}"/>
+                <a16:creationId xmlns:a16="http://schemas.microsoft.com/office/drawing/2014/main" id="{9470C596-21F3-4ACF-B9CB-6D5F81F0ECE8}"/>
               </a:ext>
             </a:extLst>
           </p:cNvPr>
@@ -13633,7 +15306,7 @@
           <p:cNvPr id="2" name="">
             <a:extLst xmlns:a="http://schemas.openxmlformats.org/drawingml/2006/main">
               <a:ext uri="{FF2B5EF4-FFF2-40B4-BE49-F238E27FC236}">
-                <a16:creationId xmlns:a16="http://schemas.microsoft.com/office/drawing/2014/main" id="{5C03C6D9-6328-4B7C-BC3B-C4D66902A34C}"/>
+                <a16:creationId xmlns:a16="http://schemas.microsoft.com/office/drawing/2014/main" id="{27E95B15-7A14-4032-A4E9-2D256875987A}"/>
               </a:ext>
             </a:extLst>
           </p:cNvPr>
@@ -13789,7 +15462,7 @@
           <p:cNvPr id="3" name="">
             <a:extLst xmlns:a="http://schemas.openxmlformats.org/drawingml/2006/main">
               <a:ext uri="{FF2B5EF4-FFF2-40B4-BE49-F238E27FC236}">
-                <a16:creationId xmlns:a16="http://schemas.microsoft.com/office/drawing/2014/main" id="{50E84087-742E-4948-8065-4924AD96F369}"/>
+                <a16:creationId xmlns:a16="http://schemas.microsoft.com/office/drawing/2014/main" id="{71AF7561-8EFC-4B6C-B0D4-8B0D23DA7BF0}"/>
               </a:ext>
             </a:extLst>
           </p:cNvPr>
@@ -13945,7 +15618,7 @@
           <p:cNvPr id="4" name="">
             <a:extLst xmlns:a="http://schemas.openxmlformats.org/drawingml/2006/main">
               <a:ext uri="{FF2B5EF4-FFF2-40B4-BE49-F238E27FC236}">
-                <a16:creationId xmlns:a16="http://schemas.microsoft.com/office/drawing/2014/main" id="{08F1A764-9D52-4033-B7A4-79A8C12C81C9}"/>
+                <a16:creationId xmlns:a16="http://schemas.microsoft.com/office/drawing/2014/main" id="{AE031F4F-F372-4CE5-864C-7FD50F262F63}"/>
               </a:ext>
             </a:extLst>
           </p:cNvPr>
@@ -14101,7 +15774,7 @@
           <p:cNvPr id="5" name="">
             <a:extLst xmlns:a="http://schemas.openxmlformats.org/drawingml/2006/main">
               <a:ext uri="{FF2B5EF4-FFF2-40B4-BE49-F238E27FC236}">
-                <a16:creationId xmlns:a16="http://schemas.microsoft.com/office/drawing/2014/main" id="{EAEAF682-57AD-4BC5-BA01-87822F6825B3}"/>
+                <a16:creationId xmlns:a16="http://schemas.microsoft.com/office/drawing/2014/main" id="{09A03D8A-9E33-4241-84C2-88C31347555A}"/>
               </a:ext>
             </a:extLst>
           </p:cNvPr>
@@ -14728,7 +16401,7 @@
           <p:cNvPr id="6" name="">
             <a:extLst xmlns:a="http://schemas.openxmlformats.org/drawingml/2006/main">
               <a:ext uri="{FF2B5EF4-FFF2-40B4-BE49-F238E27FC236}">
-                <a16:creationId xmlns:a16="http://schemas.microsoft.com/office/drawing/2014/main" id="{1D609E1A-2B36-4283-9DFC-2586769E4770}"/>
+                <a16:creationId xmlns:a16="http://schemas.microsoft.com/office/drawing/2014/main" id="{382C8863-C86D-4F6F-968A-5CEF6E9BF931}"/>
               </a:ext>
             </a:extLst>
           </p:cNvPr>
@@ -14874,7 +16547,7 @@
                 <a:ea typeface="Apple SD Gothic Neo"/>
                 <a:cs typeface="Apple SD Gothic Neo"/>
               </a:rPr>
-              <a:t>각 행은 별도 실험입니다. 같은 재생의 지연은 미계측이며 p50/p95는 N/A입니다. 원본 화면은 README §9.</a:t>
+              <a:t>각 행은 별도 실험입니다. 단계별 재생의 지연은 미계측이며 별도 백엔드 비교와 구분합니다. 원본 화면은 README §9.</a:t>
             </a:r>
           </a:p>
         </p:txBody>
@@ -14882,7 +16555,7 @@
     </p:spTree>
     <p:extLst>
       <p:ext uri="{BB962C8B-B14F-4D97-AF65-F5344CB8AC3E}">
-        <p14:creationId xmlns:p14="http://schemas.microsoft.com/office/powerpoint/2010/main" val="679099710"/>
+        <p14:creationId xmlns:p14="http://schemas.microsoft.com/office/powerpoint/2010/main" val="41062367"/>
       </p:ext>
     </p:extLst>
   </p:cSld>
@@ -14913,7 +16586,7 @@
           <p:cNvPr id="7" name="">
             <a:extLst xmlns:a="http://schemas.openxmlformats.org/drawingml/2006/main">
               <a:ext uri="{FF2B5EF4-FFF2-40B4-BE49-F238E27FC236}">
-                <a16:creationId xmlns:a16="http://schemas.microsoft.com/office/drawing/2014/main" id="{C8F1C9D1-6F6B-4D5F-8DBF-9406BBA33000}"/>
+                <a16:creationId xmlns:a16="http://schemas.microsoft.com/office/drawing/2014/main" id="{CF5FD5C0-05EF-4DFD-9BC7-99C234A5CC13}"/>
               </a:ext>
             </a:extLst>
           </p:cNvPr>
@@ -15069,7 +16742,7 @@
           <p:cNvPr id="2" name="">
             <a:extLst xmlns:a="http://schemas.openxmlformats.org/drawingml/2006/main">
               <a:ext uri="{FF2B5EF4-FFF2-40B4-BE49-F238E27FC236}">
-                <a16:creationId xmlns:a16="http://schemas.microsoft.com/office/drawing/2014/main" id="{048E9569-8174-4289-A68B-F61ADBEEEBE8}"/>
+                <a16:creationId xmlns:a16="http://schemas.microsoft.com/office/drawing/2014/main" id="{E2A4604C-D546-4003-82C2-F11CCC10AAEF}"/>
               </a:ext>
             </a:extLst>
           </p:cNvPr>
@@ -15225,7 +16898,7 @@
           <p:cNvPr id="3" name="">
             <a:extLst xmlns:a="http://schemas.openxmlformats.org/drawingml/2006/main">
               <a:ext uri="{FF2B5EF4-FFF2-40B4-BE49-F238E27FC236}">
-                <a16:creationId xmlns:a16="http://schemas.microsoft.com/office/drawing/2014/main" id="{EF520E1F-4BC5-46DA-BD2F-674EC5DE6326}"/>
+                <a16:creationId xmlns:a16="http://schemas.microsoft.com/office/drawing/2014/main" id="{F96EAF5F-0BE9-4BEB-8CA2-DC24A36CA1FA}"/>
               </a:ext>
             </a:extLst>
           </p:cNvPr>
@@ -15381,7 +17054,7 @@
           <p:cNvPr id="4" name="">
             <a:extLst xmlns:a="http://schemas.openxmlformats.org/drawingml/2006/main">
               <a:ext uri="{FF2B5EF4-FFF2-40B4-BE49-F238E27FC236}">
-                <a16:creationId xmlns:a16="http://schemas.microsoft.com/office/drawing/2014/main" id="{10FE3D3F-BA8F-4E70-8090-6C3FCAAB7055}"/>
+                <a16:creationId xmlns:a16="http://schemas.microsoft.com/office/drawing/2014/main" id="{FBE3329D-2A6B-4544-8FDF-DC536AF36C1A}"/>
               </a:ext>
             </a:extLst>
           </p:cNvPr>
@@ -15537,7 +17210,7 @@
           <p:cNvPr id="5" name="">
             <a:extLst xmlns:a="http://schemas.openxmlformats.org/drawingml/2006/main">
               <a:ext uri="{FF2B5EF4-FFF2-40B4-BE49-F238E27FC236}">
-                <a16:creationId xmlns:a16="http://schemas.microsoft.com/office/drawing/2014/main" id="{D4112A56-12B5-4740-8B09-554078774BA0}"/>
+                <a16:creationId xmlns:a16="http://schemas.microsoft.com/office/drawing/2014/main" id="{610828FA-B779-41A2-A47B-2FB5277458DA}"/>
               </a:ext>
             </a:extLst>
           </p:cNvPr>
@@ -15822,7 +17495,7 @@
                           <a:ea typeface="Apple SD Gothic Neo"/>
                           <a:cs typeface="Apple SD Gothic Neo"/>
                         </a:rPr>
-                        <a:t>새 Qwen 기억 사례</a:t>
+                        <a:t>Qwen 기억 실패 재현</a:t>
                       </a:r>
                     </a:p>
                   </a:txBody>
@@ -15864,7 +17537,7 @@
                           <a:ea typeface="Apple SD Gothic Neo"/>
                           <a:cs typeface="Apple SD Gothic Neo"/>
                         </a:rPr>
-                        <a:t>2건 실패</a:t>
+                        <a:t>허위 근거 ID로 거부</a:t>
                       </a:r>
                     </a:p>
                   </a:txBody>
@@ -15900,7 +17573,7 @@
                           <a:ea typeface="Apple SD Gothic Neo"/>
                           <a:cs typeface="Apple SD Gothic Neo"/>
                         </a:rPr>
-                        <a:t>형식 검사만으로 의미 보존 불가</a:t>
+                        <a:t>이름은 facts에 있어도 fallback</a:t>
                       </a:r>
                     </a:p>
                   </a:txBody>
@@ -16164,7 +17837,7 @@
           <p:cNvPr id="6" name="">
             <a:extLst xmlns:a="http://schemas.openxmlformats.org/drawingml/2006/main">
               <a:ext uri="{FF2B5EF4-FFF2-40B4-BE49-F238E27FC236}">
-                <a16:creationId xmlns:a16="http://schemas.microsoft.com/office/drawing/2014/main" id="{1DA77060-0AB4-41B6-8E17-A9510FD00319}"/>
+                <a16:creationId xmlns:a16="http://schemas.microsoft.com/office/drawing/2014/main" id="{7D2862E1-7442-4AC1-A1EF-B3024E1298EF}"/>
               </a:ext>
             </a:extLst>
           </p:cNvPr>
@@ -16310,7 +17983,7 @@
                 <a:ea typeface="Apple SD Gothic Neo"/>
                 <a:cs typeface="Apple SD Gothic Neo"/>
               </a:rPr>
-              <a:t>Judge 사람 검토는 독립 4사례입니다. 동일 계열 모델 편향과 작은 표본을 한계로 남겼습니다.</a:t>
+              <a:t>Judge 사람 확인 4범주: Qwen·OpenAI 모두 방향 일치 4/4. 일반 평가 정확도의 개선은 입증하지 못했습니다.</a:t>
             </a:r>
           </a:p>
         </p:txBody>
@@ -16318,7 +17991,7 @@
     </p:spTree>
     <p:extLst>
       <p:ext uri="{BB962C8B-B14F-4D97-AF65-F5344CB8AC3E}">
-        <p14:creationId xmlns:p14="http://schemas.microsoft.com/office/powerpoint/2010/main" val="1246996573"/>
+        <p14:creationId xmlns:p14="http://schemas.microsoft.com/office/powerpoint/2010/main" val="485263150"/>
       </p:ext>
     </p:extLst>
   </p:cSld>
@@ -16349,7 +18022,7 @@
           <p:cNvPr id="16" name="">
             <a:extLst xmlns:a="http://schemas.openxmlformats.org/drawingml/2006/main">
               <a:ext uri="{FF2B5EF4-FFF2-40B4-BE49-F238E27FC236}">
-                <a16:creationId xmlns:a16="http://schemas.microsoft.com/office/drawing/2014/main" id="{6DF6530B-C933-4290-A7B5-0DD633C37163}"/>
+                <a16:creationId xmlns:a16="http://schemas.microsoft.com/office/drawing/2014/main" id="{82C88629-4AE1-4FA0-9C2E-8E4428D372F8}"/>
               </a:ext>
             </a:extLst>
           </p:cNvPr>
@@ -16505,7 +18178,7 @@
           <p:cNvPr id="2" name="">
             <a:extLst xmlns:a="http://schemas.openxmlformats.org/drawingml/2006/main">
               <a:ext uri="{FF2B5EF4-FFF2-40B4-BE49-F238E27FC236}">
-                <a16:creationId xmlns:a16="http://schemas.microsoft.com/office/drawing/2014/main" id="{5D11EC5B-A469-43FA-AA4A-1B98F4E5A95E}"/>
+                <a16:creationId xmlns:a16="http://schemas.microsoft.com/office/drawing/2014/main" id="{F20FC125-90BA-4620-BCB8-36AAFC089A79}"/>
               </a:ext>
             </a:extLst>
           </p:cNvPr>
@@ -16661,7 +18334,7 @@
           <p:cNvPr id="3" name="">
             <a:extLst xmlns:a="http://schemas.openxmlformats.org/drawingml/2006/main">
               <a:ext uri="{FF2B5EF4-FFF2-40B4-BE49-F238E27FC236}">
-                <a16:creationId xmlns:a16="http://schemas.microsoft.com/office/drawing/2014/main" id="{01474B9E-FFAA-404C-BC2D-765E32EC6CD8}"/>
+                <a16:creationId xmlns:a16="http://schemas.microsoft.com/office/drawing/2014/main" id="{9F63D491-D110-433E-9443-0173CC0B6324}"/>
               </a:ext>
             </a:extLst>
           </p:cNvPr>
@@ -16817,7 +18490,7 @@
           <p:cNvPr id="4" name="">
             <a:extLst xmlns:a="http://schemas.openxmlformats.org/drawingml/2006/main">
               <a:ext uri="{FF2B5EF4-FFF2-40B4-BE49-F238E27FC236}">
-                <a16:creationId xmlns:a16="http://schemas.microsoft.com/office/drawing/2014/main" id="{F042BE98-8086-41B7-812E-ED1FED73B422}"/>
+                <a16:creationId xmlns:a16="http://schemas.microsoft.com/office/drawing/2014/main" id="{902B59ED-B77C-462D-84DF-602F445A654E}"/>
               </a:ext>
             </a:extLst>
           </p:cNvPr>
@@ -16973,7 +18646,7 @@
           <p:cNvPr id="5" name="">
             <a:extLst xmlns:a="http://schemas.openxmlformats.org/drawingml/2006/main">
               <a:ext uri="{FF2B5EF4-FFF2-40B4-BE49-F238E27FC236}">
-                <a16:creationId xmlns:a16="http://schemas.microsoft.com/office/drawing/2014/main" id="{01DA003F-DDF0-4272-A97D-356692F3EB81}"/>
+                <a16:creationId xmlns:a16="http://schemas.microsoft.com/office/drawing/2014/main" id="{4794DBB4-4D58-40D2-8DA9-2F50C220CB99}"/>
               </a:ext>
             </a:extLst>
           </p:cNvPr>
@@ -17129,7 +18802,7 @@
           <p:cNvPr id="6" name="">
             <a:extLst xmlns:a="http://schemas.openxmlformats.org/drawingml/2006/main">
               <a:ext uri="{FF2B5EF4-FFF2-40B4-BE49-F238E27FC236}">
-                <a16:creationId xmlns:a16="http://schemas.microsoft.com/office/drawing/2014/main" id="{84B0F05A-373B-439A-AD55-AA92A6E8B870}"/>
+                <a16:creationId xmlns:a16="http://schemas.microsoft.com/office/drawing/2014/main" id="{A6E41827-9AF8-4E38-934F-8000025BA671}"/>
               </a:ext>
             </a:extLst>
           </p:cNvPr>
@@ -17285,7 +18958,7 @@
           <p:cNvPr id="7" name="">
             <a:extLst xmlns:a="http://schemas.openxmlformats.org/drawingml/2006/main">
               <a:ext uri="{FF2B5EF4-FFF2-40B4-BE49-F238E27FC236}">
-                <a16:creationId xmlns:a16="http://schemas.microsoft.com/office/drawing/2014/main" id="{27C1650B-2774-4588-863A-BAC6751ADB95}"/>
+                <a16:creationId xmlns:a16="http://schemas.microsoft.com/office/drawing/2014/main" id="{496C8630-28D5-4968-A9ED-29FC71F38B9E}"/>
               </a:ext>
             </a:extLst>
           </p:cNvPr>
@@ -17441,7 +19114,7 @@
           <p:cNvPr id="8" name="">
             <a:extLst xmlns:a="http://schemas.openxmlformats.org/drawingml/2006/main">
               <a:ext uri="{FF2B5EF4-FFF2-40B4-BE49-F238E27FC236}">
-                <a16:creationId xmlns:a16="http://schemas.microsoft.com/office/drawing/2014/main" id="{61B370B2-192C-436A-9C83-E343DFF0A3DA}"/>
+                <a16:creationId xmlns:a16="http://schemas.microsoft.com/office/drawing/2014/main" id="{5E0EEF8C-0BCB-40FC-963A-6E686771383F}"/>
               </a:ext>
             </a:extLst>
           </p:cNvPr>
@@ -17597,7 +19270,7 @@
           <p:cNvPr id="9" name="">
             <a:extLst xmlns:a="http://schemas.openxmlformats.org/drawingml/2006/main">
               <a:ext uri="{FF2B5EF4-FFF2-40B4-BE49-F238E27FC236}">
-                <a16:creationId xmlns:a16="http://schemas.microsoft.com/office/drawing/2014/main" id="{13E9098A-F553-4A13-AC7B-A3233040D5A1}"/>
+                <a16:creationId xmlns:a16="http://schemas.microsoft.com/office/drawing/2014/main" id="{92151334-2182-4AF4-88DF-5E6037F05169}"/>
               </a:ext>
             </a:extLst>
           </p:cNvPr>
@@ -17753,7 +19426,7 @@
           <p:cNvPr id="10" name="">
             <a:extLst xmlns:a="http://schemas.openxmlformats.org/drawingml/2006/main">
               <a:ext uri="{FF2B5EF4-FFF2-40B4-BE49-F238E27FC236}">
-                <a16:creationId xmlns:a16="http://schemas.microsoft.com/office/drawing/2014/main" id="{90441A72-28FB-47EF-A379-1B8ECC49D24A}"/>
+                <a16:creationId xmlns:a16="http://schemas.microsoft.com/office/drawing/2014/main" id="{D126B9E9-C7CF-4FA2-82D8-383D53FB2C06}"/>
               </a:ext>
             </a:extLst>
           </p:cNvPr>
@@ -17909,7 +19582,7 @@
           <p:cNvPr id="11" name="">
             <a:extLst xmlns:a="http://schemas.openxmlformats.org/drawingml/2006/main">
               <a:ext uri="{FF2B5EF4-FFF2-40B4-BE49-F238E27FC236}">
-                <a16:creationId xmlns:a16="http://schemas.microsoft.com/office/drawing/2014/main" id="{248DE0BF-5A59-49D3-93E4-FD545DFD9241}"/>
+                <a16:creationId xmlns:a16="http://schemas.microsoft.com/office/drawing/2014/main" id="{2B8DD41B-CD7E-43CE-87FC-20A0B682D623}"/>
               </a:ext>
             </a:extLst>
           </p:cNvPr>
@@ -18065,7 +19738,7 @@
           <p:cNvPr id="12" name="">
             <a:extLst xmlns:a="http://schemas.openxmlformats.org/drawingml/2006/main">
               <a:ext uri="{FF2B5EF4-FFF2-40B4-BE49-F238E27FC236}">
-                <a16:creationId xmlns:a16="http://schemas.microsoft.com/office/drawing/2014/main" id="{BF5A99B6-F67F-47D4-B7E4-EA731FDF4670}"/>
+                <a16:creationId xmlns:a16="http://schemas.microsoft.com/office/drawing/2014/main" id="{61F963C1-41B6-4A27-B302-E231FD1AC44C}"/>
               </a:ext>
             </a:extLst>
           </p:cNvPr>
@@ -18211,7 +19884,7 @@
                 <a:ea typeface="Apple SD Gothic Neo"/>
                 <a:cs typeface="Apple SD Gothic Neo"/>
               </a:rPr>
-              <a:t>기존 trace 확장 / SSE 중단 회귀 9개 추가</a:t>
+              <a:t>기존 trace 확장 / SSE 9개·OpenAI 응답 6개</a:t>
             </a:r>
           </a:p>
         </p:txBody>
@@ -18221,7 +19894,7 @@
           <p:cNvPr id="13" name="">
             <a:extLst xmlns:a="http://schemas.openxmlformats.org/drawingml/2006/main">
               <a:ext uri="{FF2B5EF4-FFF2-40B4-BE49-F238E27FC236}">
-                <a16:creationId xmlns:a16="http://schemas.microsoft.com/office/drawing/2014/main" id="{0DE4538D-A885-4020-8E69-49023FEA7BA7}"/>
+                <a16:creationId xmlns:a16="http://schemas.microsoft.com/office/drawing/2014/main" id="{C8178111-E519-4054-B068-F8BF8E3F497A}"/>
               </a:ext>
             </a:extLst>
           </p:cNvPr>
@@ -18377,7 +20050,7 @@
           <p:cNvPr id="14" name="">
             <a:extLst xmlns:a="http://schemas.openxmlformats.org/drawingml/2006/main">
               <a:ext uri="{FF2B5EF4-FFF2-40B4-BE49-F238E27FC236}">
-                <a16:creationId xmlns:a16="http://schemas.microsoft.com/office/drawing/2014/main" id="{8728A081-21DB-47D7-882A-AD954F5734CC}"/>
+                <a16:creationId xmlns:a16="http://schemas.microsoft.com/office/drawing/2014/main" id="{17E14311-2AAE-4085-8714-B0A6F9F4DF5F}"/>
               </a:ext>
             </a:extLst>
           </p:cNvPr>
@@ -18523,7 +20196,7 @@
                 <a:ea typeface="Apple SD Gothic Neo"/>
                 <a:cs typeface="Apple SD Gothic Neo"/>
               </a:rPr>
-              <a:t>요약 의미 보존·실제 로그·독립 Judge 검증</a:t>
+              <a:t>요약 의미 보존·실제 로그·평가 집합 확대</a:t>
             </a:r>
           </a:p>
         </p:txBody>
@@ -18533,7 +20206,7 @@
           <p:cNvPr id="15" name="">
             <a:extLst xmlns:a="http://schemas.openxmlformats.org/drawingml/2006/main">
               <a:ext uri="{FF2B5EF4-FFF2-40B4-BE49-F238E27FC236}">
-                <a16:creationId xmlns:a16="http://schemas.microsoft.com/office/drawing/2014/main" id="{62D72788-08CF-4D91-BAC9-47E1456D4C6A}"/>
+                <a16:creationId xmlns:a16="http://schemas.microsoft.com/office/drawing/2014/main" id="{A52F519B-698B-45C3-9BE3-1F3B73A6975C}"/>
               </a:ext>
             </a:extLst>
           </p:cNvPr>
@@ -18679,7 +20352,7 @@
                 <a:ea typeface="Apple SD Gothic Neo"/>
                 <a:cs typeface="Apple SD Gothic Neo"/>
               </a:rPr>
-              <a:t>전문 그래프 병행과 실제 MCP I/O 직렬을 구분합니다. 부하 시험·OpenAI 추가 검증은 아직 수행하지 않았습니다.</a:t>
+              <a:t>전체 213 PASS·13 XFAIL / 공개 116 PASS·5 XFAIL. MCP I/O 직렬·일부 OpenAI 동기 호출·부하 시험은 한계입니다.</a:t>
             </a:r>
           </a:p>
         </p:txBody>
@@ -18687,7 +20360,7 @@
     </p:spTree>
     <p:extLst>
       <p:ext uri="{BB962C8B-B14F-4D97-AF65-F5344CB8AC3E}">
-        <p14:creationId xmlns:p14="http://schemas.microsoft.com/office/powerpoint/2010/main" val="1886988323"/>
+        <p14:creationId xmlns:p14="http://schemas.microsoft.com/office/powerpoint/2010/main" val="337111828"/>
       </p:ext>
     </p:extLst>
   </p:cSld>

</xml_diff>